<commit_message>
docs: Revise the agent handoff slides after review
Clearer wording, numerals, the shared topic list, likely reasons for the success-rule loss and revised limitations; fixes the backup slide's tool-access claim.
</commit_message>
<xml_diff>
--- a/experiments/agent-handoff-2026-10-19/Agent_Handoff_Results.pptx
+++ b/experiments/agent-handoff-2026-10-19/Agent_Handoff_Results.pptx
@@ -565,7 +565,7 @@
             </c:spPr>
             <c:extLst>
               <c:ext xmlns:c16="http://schemas.microsoft.com/office/drawing/2014/chart" uri="{C3380CC4-5D6E-409C-BE32-E72D297353CC}">
-                <c16:uniqueId val="{00000001-1F59-4B8D-A3AA-D6AB788858FB}"/>
+                <c16:uniqueId val="{00000001-7B7C-4B93-AC53-B4DD4CFEEB74}"/>
               </c:ext>
             </c:extLst>
           </c:dPt>
@@ -880,7 +880,7 @@
           <a:p>
             <a:fld id="{7BAD5A2C-7A87-4C6E-B9D5-E78D2408C15A}" type="datetimeFigureOut">
               <a:rPr lang="en-SG" smtClean="0"/>
-              <a:t>19/10/2026</a:t>
+              <a:t>20/10/2026</a:t>
             </a:fld>
             <a:endParaRPr lang="en-SG"/>
           </a:p>
@@ -1394,7 +1394,7 @@
           <a:p>
             <a:r>
               <a:rPr lang="en-SG" dirty="0"/>
-              <a:t>Over-length handoffs: Claude Opus 5.5 checklists 5 of 5, Claude Sonnet 5.5 checklists 4 of 5, Claude Opus 5.5 summaries 3 of 5; no GPT handoff went over. "The formats ended up alike" comes from reading the 20 free-form summaries: nearly all still name each requested part inline ("Agent/status: ... Inputs: ...").</a:t>
+              <a:t>Coding runs 4 and 5 were added after seeing the results of runs 1 to 3, so the five-run comparison is exploratory. Every handoff was read by the same Claude Opus 5.5 receiving agent, and Opus also did the coding. Over-length handoffs: Claude Opus 5.5 checklists 5 of 5, Claude Sonnet 5.5 checklists 4 of 5, Claude Opus 5.5 summaries 3 of 5; no GPT handoff went over. "The formats ended up alike" comes from reading the 20 free-form summaries: nearly all still name each requested part inline ("Agent/status: ... Inputs: ...").</a:t>
             </a:r>
           </a:p>
           <a:p>
@@ -1700,7 +1700,16 @@
           <a:p>
             <a:r>
               <a:rPr lang="en-SG" dirty="0"/>
-              <a:t>The coding agent worked in an offline, read-only container with an unprivileged user; only llm.py was writable. The starting code failed 5 of the 30 tests and errored on 4; a private reference repair passed all 30 and was kept out of the coding agent's inputs. Claude sessions exposed no tools. OpenAI sessions kept their built-in tool definitions under an agreed, audited exception; audits of what the client recorded found no tool calls and no incomplete audits. All agents used medium effort, which is not equal compute across providers. Eight preliminary handoffs were excluded after a transcript-rendering fix, and one incomplete setup attempt for the extra runs was excluded before any scored handoffs; their raw evidence is preserved.</a:t>
+              <a:t>The coding agent worked in an offline, read-only container with an unprivileged user; only llm.py was writable. The starting code failed 5 of the 30 tests and errored on 4; a private reference repair passed all 30 and was kept out of the coding agent's inputs. Claude sessions exposed no tools. OpenAI sessions kept their built-in tool definitions under an agreed, audited exception; audits of what the client recorded found no tool calls and no incomplete audits. All agents used medium effort, which is not equal compute across providers. Eight preliminary handoffs were excluded after a transcript-rendering fix, and one incomplete setup attempt for the extra runs was excluded before any scored handoffs; their raw evidence is preserved. The audit covers only events the clients recorded.</a:t>
+            </a:r>
+          </a:p>
+          <a:p>
+            <a:endParaRPr lang="en-SG" dirty="0"/>
+          </a:p>
+          <a:p>
+            <a:r>
+              <a:rPr lang="en-SG" dirty="0"/>
+              <a:t>Changes from the original plan: it named GPT-6.1 Sol for the coding and receiving agents, but the runs used Claude Opus 5.5; and it planned 3 coding runs, but 2 more were added after the first results.</a:t>
             </a:r>
           </a:p>
           <a:p>
@@ -2203,7 +2212,7 @@
           <a:p>
             <a:r>
               <a:rPr lang="en-SG" dirty="0"/>
-              <a:t>Every agent ran in a fresh session. The handoff and receiving agents had no tools. Neither handoff agent saw the other's handoff, and no agent saw the answer key. The receiving agent had to back each answer with exact quotes from the handoff, or say "not stated".</a:t>
+              <a:t>Every agent ran in a fresh session. Claude sessions had no tools; the OpenAI handoff sessions still had their built-in tools available under an agreed exception, and the audit found none were used. Neither handoff agent saw the other's handoff, and no agent saw the answer key. The receiving agent had to back each answer with exact quotes from the handoff, or say "not stated".</a:t>
             </a:r>
           </a:p>
           <a:p>
@@ -2212,7 +2221,7 @@
           <a:p>
             <a:r>
               <a:rPr lang="en-SG" dirty="0"/>
-              <a:t>The original plan used GPT-6.1 Sol for the coding and receiving agents and three coding runs. The runs used Claude Opus 5.5 for both, and two more coding runs were added after seeing the first three results (see the second backup slide).</a:t>
+              <a:t>The original plan used GPT-6.1 Sol for the coding and receiving agents and three coding runs. The runs used Claude Opus 5.5 for both, and two more coding runs were added after seeing the first three results.</a:t>
             </a:r>
           </a:p>
           <a:p>
@@ -2433,6 +2442,15 @@
           <a:p>
             <a:r>
               <a:rPr lang="en-SG" dirty="0"/>
+              <a:t>Within each family the more capable model scored higher in both formats: Sol 78 and 73 vs Luna 64 and 62 (14 and 11 facts more); Opus 78 and 79 vs Sonnet 74 and 75 (4 more each). The model gap is larger than any format gap.</a:t>
+            </a:r>
+          </a:p>
+          <a:p>
+            <a:endParaRPr lang="en-SG" dirty="0"/>
+          </a:p>
+          <a:p>
+            <a:r>
+              <a:rPr lang="en-SG" dirty="0"/>
               <a:t>Sources: results ZIP, model-format-results.json, before-after.json, word-counts.json, compliant-pair-sensitivity.json.</a:t>
             </a:r>
           </a:p>
@@ -2521,7 +2539,7 @@
           <a:p>
             <a:r>
               <a:rPr lang="en-SG" dirty="0"/>
-              <a:t>The success rules come from the probe's contract: status 200, valid UTF-8 JSON, a non-empty choices list, a non-blank message, and a body of at most 65,536 bytes. The bars pool all 40 handoffs. Reading the 40 handoff texts confirms the loss happened when the handoff was written: almost none mention these rules. The timeout question shows the same pattern at 45%: 35 of 40 handoffs kept the 10-second limit, but none kept the recorded reason for using one total deadline rather than a per-socket timeout.</a:t>
+              <a:t>The success rules come from the probe's contract: status 200, valid UTF-8 JSON, a non-empty choices list, a non-blank message, and a body of at most 65,536 bytes. The bars pool all 40 handoffs. Reading the 40 handoff texts confirms the loss happened when the handoff was written: almost none mention these rules. The word limit does not explain the loss: the 12 handoffs over 200 words kept 2 of their 108 success-rule facts (2%), against 2 of 252 (1%) for the rest. The success rules were not among the 5 bugs, and none of the 7 prompt topics asks for them. The timeout question shows the same pattern at 45%: 35 of 40 handoffs kept the 10-second limit, but none kept the recorded reason for using one total deadline rather than a per-socket timeout.</a:t>
             </a:r>
           </a:p>
           <a:p>
@@ -2715,7 +2733,7 @@
           <a:p>
             <a:fld id="{61668A28-7029-416B-BE36-2AAE1D402D3B}" type="datetimeFigureOut">
               <a:rPr lang="en-SG" smtClean="0"/>
-              <a:t>19/10/2026</a:t>
+              <a:t>20/10/2026</a:t>
             </a:fld>
             <a:endParaRPr lang="en-SG"/>
           </a:p>
@@ -2915,7 +2933,7 @@
           <a:p>
             <a:fld id="{61668A28-7029-416B-BE36-2AAE1D402D3B}" type="datetimeFigureOut">
               <a:rPr lang="en-SG" smtClean="0"/>
-              <a:t>19/10/2026</a:t>
+              <a:t>20/10/2026</a:t>
             </a:fld>
             <a:endParaRPr lang="en-SG"/>
           </a:p>
@@ -3125,7 +3143,7 @@
           <a:p>
             <a:fld id="{61668A28-7029-416B-BE36-2AAE1D402D3B}" type="datetimeFigureOut">
               <a:rPr lang="en-SG" smtClean="0"/>
-              <a:t>19/10/2026</a:t>
+              <a:t>20/10/2026</a:t>
             </a:fld>
             <a:endParaRPr lang="en-SG"/>
           </a:p>
@@ -3325,7 +3343,7 @@
           <a:p>
             <a:fld id="{61668A28-7029-416B-BE36-2AAE1D402D3B}" type="datetimeFigureOut">
               <a:rPr lang="en-SG" smtClean="0"/>
-              <a:t>19/10/2026</a:t>
+              <a:t>20/10/2026</a:t>
             </a:fld>
             <a:endParaRPr lang="en-SG"/>
           </a:p>
@@ -3601,7 +3619,7 @@
           <a:p>
             <a:fld id="{61668A28-7029-416B-BE36-2AAE1D402D3B}" type="datetimeFigureOut">
               <a:rPr lang="en-SG" smtClean="0"/>
-              <a:t>19/10/2026</a:t>
+              <a:t>20/10/2026</a:t>
             </a:fld>
             <a:endParaRPr lang="en-SG"/>
           </a:p>
@@ -3869,7 +3887,7 @@
           <a:p>
             <a:fld id="{61668A28-7029-416B-BE36-2AAE1D402D3B}" type="datetimeFigureOut">
               <a:rPr lang="en-SG" smtClean="0"/>
-              <a:t>19/10/2026</a:t>
+              <a:t>20/10/2026</a:t>
             </a:fld>
             <a:endParaRPr lang="en-SG"/>
           </a:p>
@@ -4284,7 +4302,7 @@
           <a:p>
             <a:fld id="{61668A28-7029-416B-BE36-2AAE1D402D3B}" type="datetimeFigureOut">
               <a:rPr lang="en-SG" smtClean="0"/>
-              <a:t>19/10/2026</a:t>
+              <a:t>20/10/2026</a:t>
             </a:fld>
             <a:endParaRPr lang="en-SG"/>
           </a:p>
@@ -4426,7 +4444,7 @@
           <a:p>
             <a:fld id="{61668A28-7029-416B-BE36-2AAE1D402D3B}" type="datetimeFigureOut">
               <a:rPr lang="en-SG" smtClean="0"/>
-              <a:t>19/10/2026</a:t>
+              <a:t>20/10/2026</a:t>
             </a:fld>
             <a:endParaRPr lang="en-SG"/>
           </a:p>
@@ -4539,7 +4557,7 @@
           <a:p>
             <a:fld id="{61668A28-7029-416B-BE36-2AAE1D402D3B}" type="datetimeFigureOut">
               <a:rPr lang="en-SG" smtClean="0"/>
-              <a:t>19/10/2026</a:t>
+              <a:t>20/10/2026</a:t>
             </a:fld>
             <a:endParaRPr lang="en-SG"/>
           </a:p>
@@ -4852,7 +4870,7 @@
           <a:p>
             <a:fld id="{61668A28-7029-416B-BE36-2AAE1D402D3B}" type="datetimeFigureOut">
               <a:rPr lang="en-SG" smtClean="0"/>
-              <a:t>19/10/2026</a:t>
+              <a:t>20/10/2026</a:t>
             </a:fld>
             <a:endParaRPr lang="en-SG"/>
           </a:p>
@@ -5141,7 +5159,7 @@
           <a:p>
             <a:fld id="{61668A28-7029-416B-BE36-2AAE1D402D3B}" type="datetimeFigureOut">
               <a:rPr lang="en-SG" smtClean="0"/>
-              <a:t>19/10/2026</a:t>
+              <a:t>20/10/2026</a:t>
             </a:fld>
             <a:endParaRPr lang="en-SG"/>
           </a:p>
@@ -5384,7 +5402,7 @@
           <a:p>
             <a:fld id="{61668A28-7029-416B-BE36-2AAE1D402D3B}" type="datetimeFigureOut">
               <a:rPr lang="en-SG" smtClean="0"/>
-              <a:t>19/10/2026</a:t>
+              <a:t>20/10/2026</a:t>
             </a:fld>
             <a:endParaRPr lang="en-SG"/>
           </a:p>
@@ -7962,7 +7980,7 @@
       </p:sp>
       <p:sp>
         <p:nvSpPr>
-          <p:cNvPr id="6" name="Limit 1" descr="One coding task. And a quiz, not real follow-up work."/>
+          <p:cNvPr id="6" name="Limit 1" descr="1 coding task. And a quiz, not real follow-up work."/>
           <p:cNvSpPr/>
           <p:nvPr/>
         </p:nvSpPr>
@@ -8033,7 +8051,7 @@
                 <a:latin typeface="Arial"/>
                 <a:cs typeface="Arial"/>
               </a:rPr>
-              <a:t>1</a:t>
+              <a:t>&lt;/&gt;</a:t>
             </a:r>
           </a:p>
         </p:txBody>
@@ -8083,7 +8101,7 @@
                 <a:latin typeface="Arial"/>
                 <a:cs typeface="Arial"/>
               </a:rPr>
-              <a:t>One coding task</a:t>
+              <a:t>1 coding task</a:t>
             </a:r>
           </a:p>
         </p:txBody>
@@ -8140,7 +8158,7 @@
       </p:sp>
       <p:sp>
         <p:nvSpPr>
-          <p:cNvPr id="10" name="Limit 2" descr="One handoff per condition. Each was written once, with no repeats."/>
+          <p:cNvPr id="10" name="Limit 2" descr="No replicates. Each model wrote each handoff once, so randomness could explain small gaps."/>
           <p:cNvSpPr/>
           <p:nvPr/>
         </p:nvSpPr>
@@ -8261,7 +8279,7 @@
                 <a:latin typeface="Arial"/>
                 <a:cs typeface="Arial"/>
               </a:rPr>
-              <a:t>One handoff per condition</a:t>
+              <a:t>No replicates</a:t>
             </a:r>
           </a:p>
         </p:txBody>
@@ -8311,14 +8329,14 @@
                 <a:latin typeface="Arial"/>
                 <a:cs typeface="Arial"/>
               </a:rPr>
-              <a:t>Each was written once, with no repeats.</a:t>
-            </a:r>
-          </a:p>
-        </p:txBody>
-      </p:sp>
-      <p:sp>
-        <p:nvSpPr>
-          <p:cNvPr id="14" name="Limit 3" descr="The formats ended up alike. Most summaries still labelled each part inline."/>
+              <a:t>Each model wrote each handoff once, so randomness could explain small gaps.</a:t>
+            </a:r>
+          </a:p>
+        </p:txBody>
+      </p:sp>
+      <p:sp>
+        <p:nvSpPr>
+          <p:cNvPr id="14" name="Limit 3" descr="The formats ended up alike. Most free-form summaries still used labels like “Inputs:”, just within a paragraph."/>
           <p:cNvSpPr/>
           <p:nvPr/>
         </p:nvSpPr>
@@ -8489,14 +8507,14 @@
                 <a:latin typeface="Arial"/>
                 <a:cs typeface="Arial"/>
               </a:rPr>
-              <a:t>Most summaries still labelled each part inline.</a:t>
-            </a:r>
-          </a:p>
-        </p:txBody>
-      </p:sp>
-      <p:sp>
-        <p:nvSpPr>
-          <p:cNvPr id="18" name="Limit 4" descr="Some went over 200 words. 12 of 40, including 9 of the 10 Claude checklists."/>
+              <a:t>Most free-form summaries still used labels like “Inputs:”, just within a paragraph.</a:t>
+            </a:r>
+          </a:p>
+        </p:txBody>
+      </p:sp>
+      <p:sp>
+        <p:nvSpPr>
+          <p:cNvPr id="18" name="Limit 4" descr="Some went over 200 words. 12 of 40 handoffs, including 9 of the 10 Claude checklists."/>
           <p:cNvSpPr/>
           <p:nvPr/>
         </p:nvSpPr>
@@ -8560,14 +8578,14 @@
               <a:buNone/>
             </a:pPr>
             <a:r>
-              <a:rPr lang="en-SG" sz="1400" b="1" i="0" dirty="0">
+              <a:rPr lang="en-SG" sz="1200" b="1" i="0" dirty="0">
                 <a:solidFill>
                   <a:srgbClr val="FFC36A"/>
                 </a:solidFill>
                 <a:latin typeface="Arial"/>
                 <a:cs typeface="Arial"/>
               </a:rPr>
-              <a:t>12</a:t>
+              <a:t>200+</a:t>
             </a:r>
           </a:p>
         </p:txBody>
@@ -8667,14 +8685,14 @@
                 <a:latin typeface="Arial"/>
                 <a:cs typeface="Arial"/>
               </a:rPr>
-              <a:t>12 of 40, including 9 of the 10 Claude checklists.</a:t>
-            </a:r>
-          </a:p>
-        </p:txBody>
-      </p:sp>
-      <p:sp>
-        <p:nvSpPr>
-          <p:cNvPr id="22" name="Limit 5" descr="Two runs added late. Runs 4 and 5 came after I saw runs 1 to 3."/>
+              <a:t>12 of 40 handoffs, including 9 of the 10 Claude checklists.</a:t>
+            </a:r>
+          </a:p>
+        </p:txBody>
+      </p:sp>
+      <p:sp>
+        <p:nvSpPr>
+          <p:cNvPr id="22" name="Limit 5" descr="1 reader model. Claude Opus 5.5 read every handoff, which may suit Claude-written ones."/>
           <p:cNvSpPr/>
           <p:nvPr/>
         </p:nvSpPr>
@@ -8745,7 +8763,7 @@
                 <a:latin typeface="Arial"/>
                 <a:cs typeface="Arial"/>
               </a:rPr>
-              <a:t>+2</a:t>
+              <a:t>1</a:t>
             </a:r>
           </a:p>
         </p:txBody>
@@ -8795,7 +8813,7 @@
                 <a:latin typeface="Arial"/>
                 <a:cs typeface="Arial"/>
               </a:rPr>
-              <a:t>Two runs added late</a:t>
+              <a:t>1 reader model</a:t>
             </a:r>
           </a:p>
         </p:txBody>
@@ -8845,14 +8863,14 @@
                 <a:latin typeface="Arial"/>
                 <a:cs typeface="Arial"/>
               </a:rPr>
-              <a:t>Runs 4 and 5 came after I saw runs 1 to 3.</a:t>
-            </a:r>
-          </a:p>
-        </p:txBody>
-      </p:sp>
-      <p:sp>
-        <p:nvSpPr>
-          <p:cNvPr id="26" name="Limit 6" descr="AI grading, not blind. The grader could see each handoff’s format."/>
+              <a:t>Claude Opus 5.5 read every handoff, which may suit Claude-written ones.</a:t>
+            </a:r>
+          </a:p>
+        </p:txBody>
+      </p:sp>
+      <p:sp>
+        <p:nvSpPr>
+          <p:cNvPr id="26" name="Limit 6" descr="Graded by AI. An AI marked every fact, so some marks may be wrong."/>
           <p:cNvSpPr/>
           <p:nvPr/>
         </p:nvSpPr>
@@ -8973,7 +8991,7 @@
                 <a:latin typeface="Arial"/>
                 <a:cs typeface="Arial"/>
               </a:rPr>
-              <a:t>AI grading, not blind</a:t>
+              <a:t>Graded by AI</a:t>
             </a:r>
           </a:p>
         </p:txBody>
@@ -9023,7 +9041,7 @@
                 <a:latin typeface="Arial"/>
                 <a:cs typeface="Arial"/>
               </a:rPr>
-              <a:t>The grader could see each handoff’s format.</a:t>
+              <a:t>An AI marked every fact, so some marks may be wrong.</a:t>
             </a:r>
           </a:p>
         </p:txBody>
@@ -9282,34 +9300,10 @@
           </a:ln>
         </p:spPr>
         <p:txBody>
-          <a:bodyPr vert="horz" wrap="square" lIns="292608" tIns="237744" rIns="274320" bIns="182880" rtlCol="0" anchor="t">
+          <a:bodyPr vert="horz" wrap="square" lIns="292608" tIns="237744" rIns="274320" bIns="182880" rtlCol="0" anchor="ctr">
             <a:noAutofit/>
           </a:bodyPr>
           <a:lstStyle/>
-          <a:p>
-            <a:pPr marL="0" indent="0" algn="l">
-              <a:lnSpc>
-                <a:spcPct val="100000"/>
-              </a:lnSpc>
-              <a:spcBef>
-                <a:spcPts val="0"/>
-              </a:spcBef>
-              <a:spcAft>
-                <a:spcPts val="1600"/>
-              </a:spcAft>
-              <a:buNone/>
-            </a:pPr>
-            <a:r>
-              <a:rPr lang="en-SG" sz="1200" b="1" i="0" spc="100" dirty="0">
-                <a:solidFill>
-                  <a:srgbClr val="69DECC"/>
-                </a:solidFill>
-                <a:latin typeface="Arial"/>
-                <a:cs typeface="Arial"/>
-              </a:rPr>
-              <a:t>RECALL FIRST · WEEK 9</a:t>
-            </a:r>
-          </a:p>
           <a:p>
             <a:pPr marL="0" indent="0" algn="l">
               <a:lnSpc>
@@ -10007,7 +10001,7 @@
                 <a:latin typeface="Arial"/>
                 <a:cs typeface="Arial"/>
               </a:rPr>
-              <a:t>Correct facts out of 136 expected facts, across all five coding runs. No expected fact was scored wrong; the rest were not stated.</a:t>
+              <a:t>Correct facts out of 136 expected facts, across all 5 coding runs. No expected fact was scored wrong; the rest were not stated.</a:t>
             </a:r>
           </a:p>
         </p:txBody>
@@ -12759,57 +12753,7 @@
       </p:sp>
       <p:sp>
         <p:nvSpPr>
-          <p:cNvPr id="4" name="Lead"/>
-          <p:cNvSpPr txBox="1"/>
-          <p:nvPr/>
-        </p:nvSpPr>
-        <p:spPr>
-          <a:xfrm>
-            <a:off x="548640" y="1353312"/>
-            <a:ext cx="11091672" cy="731520"/>
-          </a:xfrm>
-          <a:prstGeom prst="rect">
-            <a:avLst/>
-          </a:prstGeom>
-          <a:noFill/>
-          <a:ln>
-            <a:noFill/>
-          </a:ln>
-        </p:spPr>
-        <p:txBody>
-          <a:bodyPr vert="horz" wrap="square" lIns="0" tIns="0" rIns="0" bIns="0" rtlCol="0" anchor="t">
-            <a:noAutofit/>
-          </a:bodyPr>
-          <a:lstStyle/>
-          <a:p>
-            <a:pPr marL="0" indent="0" algn="l">
-              <a:lnSpc>
-                <a:spcPct val="110000"/>
-              </a:lnSpc>
-              <a:spcBef>
-                <a:spcPts val="0"/>
-              </a:spcBef>
-              <a:spcAft>
-                <a:spcPts val="0"/>
-              </a:spcAft>
-              <a:buNone/>
-            </a:pPr>
-            <a:r>
-              <a:rPr lang="en-SG" sz="1800" b="0" i="0" dirty="0">
-                <a:solidFill>
-                  <a:srgbClr val="D6DDE8"/>
-                </a:solidFill>
-                <a:latin typeface="Arial"/>
-                <a:cs typeface="Arial"/>
-              </a:rPr>
-              <a:t>Full method, exclusions and audit details are in report.html inside the results ZIP.</a:t>
-            </a:r>
-          </a:p>
-        </p:txBody>
-      </p:sp>
-      <p:sp>
-        <p:nvSpPr>
-          <p:cNvPr id="5" name="Slide number"/>
+          <p:cNvPr id="4" name="Slide number"/>
           <p:cNvSpPr txBox="1"/>
           <p:nvPr/>
         </p:nvSpPr>
@@ -12859,13 +12803,13 @@
       </p:sp>
       <p:sp>
         <p:nvSpPr>
-          <p:cNvPr id="6" name="Same start for every coding run"/>
+          <p:cNvPr id="5" name="Same start for every coding run"/>
           <p:cNvSpPr/>
           <p:nvPr/>
         </p:nvSpPr>
         <p:spPr>
           <a:xfrm>
-            <a:off x="548640" y="2240280"/>
+            <a:off x="548640" y="1600200"/>
             <a:ext cx="5431536" cy="1645920"/>
           </a:xfrm>
           <a:prstGeom prst="roundRect">
@@ -12930,20 +12874,20 @@
                 <a:latin typeface="Arial"/>
                 <a:cs typeface="Arial"/>
               </a:rPr>
-              <a:t>A fresh copy of the same starting code, contract and 30 offline tests. Edit llm.py only; no network. All five repairs passed all 30 tests.</a:t>
-            </a:r>
-          </a:p>
-        </p:txBody>
-      </p:sp>
-      <p:sp>
-        <p:nvSpPr>
-          <p:cNvPr id="7" name="Separate agents, no peeking"/>
+              <a:t>A fresh copy of the same starting code, contract and 30 offline tests. All 5 repairs passed all 30 tests.</a:t>
+            </a:r>
+          </a:p>
+        </p:txBody>
+      </p:sp>
+      <p:sp>
+        <p:nvSpPr>
+          <p:cNvPr id="6" name="Separate agents, no peeking"/>
           <p:cNvSpPr/>
           <p:nvPr/>
         </p:nvSpPr>
         <p:spPr>
           <a:xfrm>
-            <a:off x="6208776" y="2240280"/>
+            <a:off x="6208776" y="1600200"/>
             <a:ext cx="5431536" cy="1645920"/>
           </a:xfrm>
           <a:prstGeom prst="roundRect">
@@ -13008,20 +12952,20 @@
                 <a:latin typeface="Arial"/>
                 <a:cs typeface="Arial"/>
               </a:rPr>
-              <a:t>Fresh sessions. Handoff and receiving agents had no tools. No agent saw the other handoff or the answer key.</a:t>
-            </a:r>
-          </a:p>
-        </p:txBody>
-      </p:sp>
-      <p:sp>
-        <p:nvSpPr>
-          <p:cNvPr id="8" name="Fixed before the handoffs"/>
+              <a:t>Every agent started in a fresh session. No agent saw the other handoff or the answer key.</a:t>
+            </a:r>
+          </a:p>
+        </p:txBody>
+      </p:sp>
+      <p:sp>
+        <p:nvSpPr>
+          <p:cNvPr id="7" name="Fixed before the handoffs"/>
           <p:cNvSpPr/>
           <p:nvPr/>
         </p:nvSpPr>
         <p:spPr>
           <a:xfrm>
-            <a:off x="548640" y="4114800"/>
+            <a:off x="548640" y="3474720"/>
             <a:ext cx="5431536" cy="1645920"/>
           </a:xfrm>
           <a:prstGeom prst="roundRect">
@@ -13086,20 +13030,20 @@
                 <a:latin typeface="Arial"/>
                 <a:cs typeface="Arial"/>
               </a:rPr>
-              <a:t>Questions, prompts and each run’s answer key were frozen before that run’s handoffs were written. Runs 4 and 5 reused the same questions and prompts.</a:t>
-            </a:r>
-          </a:p>
-        </p:txBody>
-      </p:sp>
-      <p:sp>
-        <p:nvSpPr>
-          <p:cNvPr id="9" name="Changes from the original plan"/>
+              <a:t>Questions, prompts and each run’s answer key were frozen before that run’s handoffs were written.</a:t>
+            </a:r>
+          </a:p>
+        </p:txBody>
+      </p:sp>
+      <p:sp>
+        <p:nvSpPr>
+          <p:cNvPr id="8" name="Isolated and audited"/>
           <p:cNvSpPr/>
           <p:nvPr/>
         </p:nvSpPr>
         <p:spPr>
           <a:xfrm>
-            <a:off x="6208776" y="4114800"/>
+            <a:off x="6208776" y="3474720"/>
             <a:ext cx="5431536" cy="1645920"/>
           </a:xfrm>
           <a:prstGeom prst="roundRect">
@@ -13135,12 +13079,12 @@
             <a:r>
               <a:rPr lang="en-SG" sz="1600" b="1" i="0" dirty="0">
                 <a:solidFill>
-                  <a:srgbClr val="FFC36A"/>
-                </a:solidFill>
-                <a:latin typeface="Arial"/>
-                <a:cs typeface="Arial"/>
-              </a:rPr>
-              <a:t>Changes from the original plan</a:t>
+                  <a:srgbClr val="F5F3EB"/>
+                </a:solidFill>
+                <a:latin typeface="Arial"/>
+                <a:cs typeface="Arial"/>
+              </a:rPr>
+              <a:t>Isolated and audited</a:t>
             </a:r>
           </a:p>
           <a:p>
@@ -13164,7 +13108,7 @@
                 <a:latin typeface="Arial"/>
                 <a:cs typeface="Arial"/>
               </a:rPr>
-              <a:t>The plan named GPT-6.1 Sol for the coding and receiving agents; the runs used Claude Opus 5.5. Five coding runs instead of three; two were added after the first results.</a:t>
+              <a:t>The coding agent could only read its 3 files, rewrite llm.py and run the tests, with no network or other commands. Records of all 110 scored model calls showed no other tool use.</a:t>
             </a:r>
           </a:p>
         </p:txBody>
@@ -14316,7 +14260,7 @@
                 <a:latin typeface="Arial"/>
                 <a:cs typeface="Arial"/>
               </a:rPr>
-              <a:t>Each handoff uses a fixed checklist. If it drops something important, every later agent works without it.</a:t>
+              <a:t>Each handoff uses a fixed checklist. If it drops something important, all subsequent agents work without it.</a:t>
             </a:r>
           </a:p>
         </p:txBody>
@@ -14394,7 +14338,7 @@
                 <a:latin typeface="Arial"/>
                 <a:cs typeface="Arial"/>
               </a:rPr>
-              <a:t>Find practical ways to keep context when agents hand off work.</a:t>
+              <a:t>Find practical ways to retain context when agents hand off work.</a:t>
             </a:r>
           </a:p>
           <a:p>
@@ -15726,7 +15670,7 @@
                 <a:latin typeface="Arial"/>
                 <a:cs typeface="Arial"/>
               </a:rPr>
-              <a:t>I compared two ways of writing the same handoff.</a:t>
+              <a:t>I compared 2 ways of writing the same handoff. Both were told to cover the same 7 topics, from the same message history, in at most 200 words.</a:t>
             </a:r>
           </a:p>
         </p:txBody>
@@ -15789,12 +15733,12 @@
         </p:nvSpPr>
         <p:spPr>
           <a:xfrm>
-            <a:off x="548640" y="2011680"/>
-            <a:ext cx="5349240" cy="2743200"/>
+            <a:off x="548640" y="2057400"/>
+            <a:ext cx="5349240" cy="2103120"/>
           </a:xfrm>
           <a:prstGeom prst="roundRect">
             <a:avLst>
-              <a:gd name="adj" fmla="val 2666"/>
+              <a:gd name="adj" fmla="val 3478"/>
             </a:avLst>
           </a:prstGeom>
           <a:solidFill>
@@ -15805,7 +15749,7 @@
           </a:ln>
         </p:spPr>
         <p:txBody>
-          <a:bodyPr vert="horz" wrap="square" lIns="228600" tIns="182880" rIns="228600" bIns="91440" rtlCol="0" anchor="t">
+          <a:bodyPr vert="horz" wrap="square" lIns="228600" tIns="164592" rIns="228600" bIns="91440" rtlCol="0" anchor="t">
             <a:noAutofit/>
           </a:bodyPr>
           <a:lstStyle/>
@@ -15854,7 +15798,7 @@
                 <a:latin typeface="Arial"/>
                 <a:cs typeface="Arial"/>
               </a:rPr>
-              <a:t>Connected prose, with no headings or bullet points</a:t>
+              <a:t>The 7 topics as connected prose, with no headings or bullets</a:t>
             </a:r>
           </a:p>
         </p:txBody>
@@ -15867,7 +15811,7 @@
         </p:nvSpPr>
         <p:spPr>
           <a:xfrm>
-            <a:off x="777240" y="2926080"/>
+            <a:off x="777240" y="2880360"/>
             <a:ext cx="4892040" cy="54864"/>
           </a:xfrm>
           <a:prstGeom prst="roundRect">
@@ -15891,7 +15835,7 @@
         </p:nvSpPr>
         <p:spPr>
           <a:xfrm>
-            <a:off x="777240" y="3099816"/>
+            <a:off x="777240" y="3044952"/>
             <a:ext cx="4745279" cy="54864"/>
           </a:xfrm>
           <a:prstGeom prst="roundRect">
@@ -15915,7 +15859,7 @@
         </p:nvSpPr>
         <p:spPr>
           <a:xfrm>
-            <a:off x="777240" y="3273552"/>
+            <a:off x="777240" y="3209544"/>
             <a:ext cx="4892040" cy="54864"/>
           </a:xfrm>
           <a:prstGeom prst="roundRect">
@@ -15939,7 +15883,7 @@
         </p:nvSpPr>
         <p:spPr>
           <a:xfrm>
-            <a:off x="777240" y="3447288"/>
+            <a:off x="777240" y="3374136"/>
             <a:ext cx="4598518" cy="54864"/>
           </a:xfrm>
           <a:prstGeom prst="roundRect">
@@ -15963,7 +15907,7 @@
         </p:nvSpPr>
         <p:spPr>
           <a:xfrm>
-            <a:off x="777240" y="3621024"/>
+            <a:off x="777240" y="3538728"/>
             <a:ext cx="4843120" cy="54864"/>
           </a:xfrm>
           <a:prstGeom prst="roundRect">
@@ -15987,7 +15931,7 @@
         </p:nvSpPr>
         <p:spPr>
           <a:xfrm>
-            <a:off x="777240" y="3794760"/>
+            <a:off x="777240" y="3703320"/>
             <a:ext cx="4892040" cy="54864"/>
           </a:xfrm>
           <a:prstGeom prst="roundRect">
@@ -16011,8 +15955,8 @@
         </p:nvSpPr>
         <p:spPr>
           <a:xfrm>
-            <a:off x="777240" y="3968496"/>
-            <a:ext cx="4696358" cy="54864"/>
+            <a:off x="777240" y="3867912"/>
+            <a:ext cx="2935224" cy="54864"/>
           </a:xfrm>
           <a:prstGeom prst="roundRect">
             <a:avLst>
@@ -16029,14 +15973,142 @@
       </p:sp>
       <p:sp>
         <p:nvSpPr>
-          <p:cNvPr id="14" name="Text line"/>
+          <p:cNvPr id="14" name="Structured checklist"/>
           <p:cNvSpPr/>
           <p:nvPr/>
         </p:nvSpPr>
         <p:spPr>
           <a:xfrm>
-            <a:off x="777240" y="4142232"/>
-            <a:ext cx="4892040" cy="54864"/>
+            <a:off x="6291072" y="2057400"/>
+            <a:ext cx="5349240" cy="2103120"/>
+          </a:xfrm>
+          <a:prstGeom prst="roundRect">
+            <a:avLst>
+              <a:gd name="adj" fmla="val 3478"/>
+            </a:avLst>
+          </a:prstGeom>
+          <a:solidFill>
+            <a:srgbClr val="1B2940"/>
+          </a:solidFill>
+          <a:ln>
+            <a:noFill/>
+          </a:ln>
+        </p:spPr>
+        <p:txBody>
+          <a:bodyPr vert="horz" wrap="square" lIns="228600" tIns="164592" rIns="228600" bIns="91440" rtlCol="0" anchor="t">
+            <a:noAutofit/>
+          </a:bodyPr>
+          <a:lstStyle/>
+          <a:p>
+            <a:pPr marL="0" indent="0" algn="l">
+              <a:lnSpc>
+                <a:spcPct val="100000"/>
+              </a:lnSpc>
+              <a:spcBef>
+                <a:spcPts val="0"/>
+              </a:spcBef>
+              <a:spcAft>
+                <a:spcPts val="200"/>
+              </a:spcAft>
+              <a:buNone/>
+            </a:pPr>
+            <a:r>
+              <a:rPr lang="en-SG" sz="1300" b="1" i="0" spc="100" dirty="0">
+                <a:solidFill>
+                  <a:srgbClr val="69DECC"/>
+                </a:solidFill>
+                <a:latin typeface="Arial"/>
+                <a:cs typeface="Arial"/>
+              </a:rPr>
+              <a:t>STRUCTURED CHECKLIST</a:t>
+            </a:r>
+          </a:p>
+          <a:p>
+            <a:pPr marL="0" indent="0" algn="l">
+              <a:lnSpc>
+                <a:spcPct val="100000"/>
+              </a:lnSpc>
+              <a:spcBef>
+                <a:spcPts val="0"/>
+              </a:spcBef>
+              <a:spcAft>
+                <a:spcPts val="0"/>
+              </a:spcAft>
+              <a:buNone/>
+            </a:pPr>
+            <a:r>
+              <a:rPr lang="en-SG" sz="1300" b="0" i="0" dirty="0">
+                <a:solidFill>
+                  <a:srgbClr val="B9C4D5"/>
+                </a:solidFill>
+                <a:latin typeface="Arial"/>
+                <a:cs typeface="Arial"/>
+              </a:rPr>
+              <a:t>The 7 topics as fixed fields, like our MP3 handoffs</a:t>
+            </a:r>
+          </a:p>
+        </p:txBody>
+      </p:sp>
+      <p:sp>
+        <p:nvSpPr>
+          <p:cNvPr id="15" name="Field"/>
+          <p:cNvSpPr txBox="1"/>
+          <p:nvPr/>
+        </p:nvSpPr>
+        <p:spPr>
+          <a:xfrm>
+            <a:off x="6519672" y="2770632"/>
+            <a:ext cx="2194560" cy="182880"/>
+          </a:xfrm>
+          <a:prstGeom prst="rect">
+            <a:avLst/>
+          </a:prstGeom>
+          <a:noFill/>
+          <a:ln>
+            <a:noFill/>
+          </a:ln>
+        </p:spPr>
+        <p:txBody>
+          <a:bodyPr vert="horz" wrap="square" lIns="0" tIns="0" rIns="0" bIns="0" rtlCol="0" anchor="ctr">
+            <a:noAutofit/>
+          </a:bodyPr>
+          <a:lstStyle/>
+          <a:p>
+            <a:pPr marL="0" indent="0" algn="l">
+              <a:lnSpc>
+                <a:spcPct val="100000"/>
+              </a:lnSpc>
+              <a:spcBef>
+                <a:spcPts val="0"/>
+              </a:spcBef>
+              <a:spcAft>
+                <a:spcPts val="0"/>
+              </a:spcAft>
+              <a:buNone/>
+            </a:pPr>
+            <a:r>
+              <a:rPr lang="en-SG" sz="1150" b="1" i="0" dirty="0">
+                <a:solidFill>
+                  <a:srgbClr val="69DECC"/>
+                </a:solidFill>
+                <a:latin typeface="Arial"/>
+                <a:cs typeface="Arial"/>
+              </a:rPr>
+              <a:t>Agent and Status</a:t>
+            </a:r>
+          </a:p>
+        </p:txBody>
+      </p:sp>
+      <p:sp>
+        <p:nvSpPr>
+          <p:cNvPr id="16" name="Text line"/>
+          <p:cNvSpPr/>
+          <p:nvPr/>
+        </p:nvSpPr>
+        <p:spPr>
+          <a:xfrm>
+            <a:off x="8778240" y="2834640"/>
+            <a:ext cx="2345436" cy="54864"/>
           </a:xfrm>
           <a:prstGeom prst="roundRect">
             <a:avLst>
@@ -16053,14 +16125,64 @@
       </p:sp>
       <p:sp>
         <p:nvSpPr>
-          <p:cNvPr id="15" name="Text line"/>
+          <p:cNvPr id="17" name="Field"/>
+          <p:cNvSpPr txBox="1"/>
+          <p:nvPr/>
+        </p:nvSpPr>
+        <p:spPr>
+          <a:xfrm>
+            <a:off x="6519672" y="2958084"/>
+            <a:ext cx="2194560" cy="182880"/>
+          </a:xfrm>
+          <a:prstGeom prst="rect">
+            <a:avLst/>
+          </a:prstGeom>
+          <a:noFill/>
+          <a:ln>
+            <a:noFill/>
+          </a:ln>
+        </p:spPr>
+        <p:txBody>
+          <a:bodyPr vert="horz" wrap="square" lIns="0" tIns="0" rIns="0" bIns="0" rtlCol="0" anchor="ctr">
+            <a:noAutofit/>
+          </a:bodyPr>
+          <a:lstStyle/>
+          <a:p>
+            <a:pPr marL="0" indent="0" algn="l">
+              <a:lnSpc>
+                <a:spcPct val="100000"/>
+              </a:lnSpc>
+              <a:spcBef>
+                <a:spcPts val="0"/>
+              </a:spcBef>
+              <a:spcAft>
+                <a:spcPts val="0"/>
+              </a:spcAft>
+              <a:buNone/>
+            </a:pPr>
+            <a:r>
+              <a:rPr lang="en-SG" sz="1150" b="1" i="0" dirty="0">
+                <a:solidFill>
+                  <a:srgbClr val="69DECC"/>
+                </a:solidFill>
+                <a:latin typeface="Arial"/>
+                <a:cs typeface="Arial"/>
+              </a:rPr>
+              <a:t>Inputs</a:t>
+            </a:r>
+          </a:p>
+        </p:txBody>
+      </p:sp>
+      <p:sp>
+        <p:nvSpPr>
+          <p:cNvPr id="18" name="Text line"/>
           <p:cNvSpPr/>
           <p:nvPr/>
         </p:nvSpPr>
         <p:spPr>
           <a:xfrm>
-            <a:off x="777240" y="4315968"/>
-            <a:ext cx="4794199" cy="54864"/>
+            <a:off x="8778240" y="3022092"/>
+            <a:ext cx="1954530" cy="54864"/>
           </a:xfrm>
           <a:prstGeom prst="roundRect">
             <a:avLst>
@@ -16077,14 +16199,64 @@
       </p:sp>
       <p:sp>
         <p:nvSpPr>
-          <p:cNvPr id="16" name="Text line"/>
+          <p:cNvPr id="19" name="Field"/>
+          <p:cNvSpPr txBox="1"/>
+          <p:nvPr/>
+        </p:nvSpPr>
+        <p:spPr>
+          <a:xfrm>
+            <a:off x="6519672" y="3145536"/>
+            <a:ext cx="2194560" cy="182880"/>
+          </a:xfrm>
+          <a:prstGeom prst="rect">
+            <a:avLst/>
+          </a:prstGeom>
+          <a:noFill/>
+          <a:ln>
+            <a:noFill/>
+          </a:ln>
+        </p:spPr>
+        <p:txBody>
+          <a:bodyPr vert="horz" wrap="square" lIns="0" tIns="0" rIns="0" bIns="0" rtlCol="0" anchor="ctr">
+            <a:noAutofit/>
+          </a:bodyPr>
+          <a:lstStyle/>
+          <a:p>
+            <a:pPr marL="0" indent="0" algn="l">
+              <a:lnSpc>
+                <a:spcPct val="100000"/>
+              </a:lnSpc>
+              <a:spcBef>
+                <a:spcPts val="0"/>
+              </a:spcBef>
+              <a:spcAft>
+                <a:spcPts val="0"/>
+              </a:spcAft>
+              <a:buNone/>
+            </a:pPr>
+            <a:r>
+              <a:rPr lang="en-SG" sz="1150" b="1" i="0" dirty="0">
+                <a:solidFill>
+                  <a:srgbClr val="69DECC"/>
+                </a:solidFill>
+                <a:latin typeface="Arial"/>
+                <a:cs typeface="Arial"/>
+              </a:rPr>
+              <a:t>Changed</a:t>
+            </a:r>
+          </a:p>
+        </p:txBody>
+      </p:sp>
+      <p:sp>
+        <p:nvSpPr>
+          <p:cNvPr id="20" name="Text line"/>
           <p:cNvSpPr/>
           <p:nvPr/>
         </p:nvSpPr>
         <p:spPr>
           <a:xfrm>
-            <a:off x="777240" y="4489704"/>
-            <a:ext cx="2690622" cy="54864"/>
+            <a:off x="8778240" y="3209544"/>
+            <a:ext cx="1433322" cy="54864"/>
           </a:xfrm>
           <a:prstGeom prst="roundRect">
             <a:avLst>
@@ -16101,92 +16273,14 @@
       </p:sp>
       <p:sp>
         <p:nvSpPr>
-          <p:cNvPr id="17" name="Structured checklist"/>
-          <p:cNvSpPr/>
-          <p:nvPr/>
-        </p:nvSpPr>
-        <p:spPr>
-          <a:xfrm>
-            <a:off x="6291072" y="2011680"/>
-            <a:ext cx="5349240" cy="2743200"/>
-          </a:xfrm>
-          <a:prstGeom prst="roundRect">
-            <a:avLst>
-              <a:gd name="adj" fmla="val 2666"/>
-            </a:avLst>
-          </a:prstGeom>
-          <a:solidFill>
-            <a:srgbClr val="1B2940"/>
-          </a:solidFill>
-          <a:ln>
-            <a:noFill/>
-          </a:ln>
-        </p:spPr>
-        <p:txBody>
-          <a:bodyPr vert="horz" wrap="square" lIns="228600" tIns="182880" rIns="228600" bIns="91440" rtlCol="0" anchor="t">
-            <a:noAutofit/>
-          </a:bodyPr>
-          <a:lstStyle/>
-          <a:p>
-            <a:pPr marL="0" indent="0" algn="l">
-              <a:lnSpc>
-                <a:spcPct val="100000"/>
-              </a:lnSpc>
-              <a:spcBef>
-                <a:spcPts val="0"/>
-              </a:spcBef>
-              <a:spcAft>
-                <a:spcPts val="200"/>
-              </a:spcAft>
-              <a:buNone/>
-            </a:pPr>
-            <a:r>
-              <a:rPr lang="en-SG" sz="1300" b="1" i="0" spc="100" dirty="0">
-                <a:solidFill>
-                  <a:srgbClr val="69DECC"/>
-                </a:solidFill>
-                <a:latin typeface="Arial"/>
-                <a:cs typeface="Arial"/>
-              </a:rPr>
-              <a:t>STRUCTURED CHECKLIST</a:t>
-            </a:r>
-          </a:p>
-          <a:p>
-            <a:pPr marL="0" indent="0" algn="l">
-              <a:lnSpc>
-                <a:spcPct val="100000"/>
-              </a:lnSpc>
-              <a:spcBef>
-                <a:spcPts val="0"/>
-              </a:spcBef>
-              <a:spcAft>
-                <a:spcPts val="0"/>
-              </a:spcAft>
-              <a:buNone/>
-            </a:pPr>
-            <a:r>
-              <a:rPr lang="en-SG" sz="1300" b="0" i="0" dirty="0">
-                <a:solidFill>
-                  <a:srgbClr val="B9C4D5"/>
-                </a:solidFill>
-                <a:latin typeface="Arial"/>
-                <a:cs typeface="Arial"/>
-              </a:rPr>
-              <a:t>Fixed fields: the same ones our MP3 handoffs use</a:t>
-            </a:r>
-          </a:p>
-        </p:txBody>
-      </p:sp>
-      <p:sp>
-        <p:nvSpPr>
-          <p:cNvPr id="18" name="Field"/>
+          <p:cNvPr id="21" name="Field"/>
           <p:cNvSpPr txBox="1"/>
           <p:nvPr/>
         </p:nvSpPr>
         <p:spPr>
           <a:xfrm>
-            <a:off x="6519672" y="2816352"/>
-            <a:ext cx="2194560" cy="237744"/>
+            <a:off x="6519672" y="3332988"/>
+            <a:ext cx="2194560" cy="182880"/>
           </a:xfrm>
           <a:prstGeom prst="rect">
             <a:avLst/>
@@ -16215,28 +16309,28 @@
               <a:buNone/>
             </a:pPr>
             <a:r>
-              <a:rPr lang="en-SG" sz="1200" b="1" i="0" dirty="0">
+              <a:rPr lang="en-SG" sz="1150" b="1" i="0" dirty="0">
                 <a:solidFill>
                   <a:srgbClr val="69DECC"/>
                 </a:solidFill>
                 <a:latin typeface="Arial"/>
                 <a:cs typeface="Arial"/>
               </a:rPr>
-              <a:t>Agent and Status</a:t>
-            </a:r>
-          </a:p>
-        </p:txBody>
-      </p:sp>
-      <p:sp>
-        <p:nvSpPr>
-          <p:cNvPr id="19" name="Text line"/>
+              <a:t>Checks</a:t>
+            </a:r>
+          </a:p>
+        </p:txBody>
+      </p:sp>
+      <p:sp>
+        <p:nvSpPr>
+          <p:cNvPr id="22" name="Text line"/>
           <p:cNvSpPr/>
           <p:nvPr/>
         </p:nvSpPr>
         <p:spPr>
           <a:xfrm>
-            <a:off x="8778240" y="2907792"/>
-            <a:ext cx="2345436" cy="54864"/>
+            <a:off x="8778240" y="3396996"/>
+            <a:ext cx="2475738" cy="54864"/>
           </a:xfrm>
           <a:prstGeom prst="roundRect">
             <a:avLst>
@@ -16253,14 +16347,14 @@
       </p:sp>
       <p:sp>
         <p:nvSpPr>
-          <p:cNvPr id="20" name="Field"/>
+          <p:cNvPr id="23" name="Field"/>
           <p:cNvSpPr txBox="1"/>
           <p:nvPr/>
         </p:nvSpPr>
         <p:spPr>
           <a:xfrm>
-            <a:off x="6519672" y="3081528"/>
-            <a:ext cx="2194560" cy="237744"/>
+            <a:off x="6519672" y="3520440"/>
+            <a:ext cx="2194560" cy="182880"/>
           </a:xfrm>
           <a:prstGeom prst="rect">
             <a:avLst/>
@@ -16289,28 +16383,28 @@
               <a:buNone/>
             </a:pPr>
             <a:r>
-              <a:rPr lang="en-SG" sz="1200" b="1" i="0" dirty="0">
+              <a:rPr lang="en-SG" sz="1150" b="1" i="0" dirty="0">
                 <a:solidFill>
                   <a:srgbClr val="69DECC"/>
                 </a:solidFill>
                 <a:latin typeface="Arial"/>
                 <a:cs typeface="Arial"/>
               </a:rPr>
-              <a:t>Inputs</a:t>
-            </a:r>
-          </a:p>
-        </p:txBody>
-      </p:sp>
-      <p:sp>
-        <p:nvSpPr>
-          <p:cNvPr id="21" name="Text line"/>
+              <a:t>Decisions needed</a:t>
+            </a:r>
+          </a:p>
+        </p:txBody>
+      </p:sp>
+      <p:sp>
+        <p:nvSpPr>
+          <p:cNvPr id="24" name="Text line"/>
           <p:cNvSpPr/>
           <p:nvPr/>
         </p:nvSpPr>
         <p:spPr>
           <a:xfrm>
-            <a:off x="8778240" y="3172968"/>
-            <a:ext cx="1954530" cy="54864"/>
+            <a:off x="8778240" y="3584448"/>
+            <a:ext cx="1563624" cy="54864"/>
           </a:xfrm>
           <a:prstGeom prst="roundRect">
             <a:avLst>
@@ -16327,14 +16421,14 @@
       </p:sp>
       <p:sp>
         <p:nvSpPr>
-          <p:cNvPr id="22" name="Field"/>
+          <p:cNvPr id="25" name="Field"/>
           <p:cNvSpPr txBox="1"/>
           <p:nvPr/>
         </p:nvSpPr>
         <p:spPr>
           <a:xfrm>
-            <a:off x="6519672" y="3346704"/>
-            <a:ext cx="2194560" cy="237744"/>
+            <a:off x="6519672" y="3707892"/>
+            <a:ext cx="2194560" cy="182880"/>
           </a:xfrm>
           <a:prstGeom prst="rect">
             <a:avLst/>
@@ -16363,28 +16457,28 @@
               <a:buNone/>
             </a:pPr>
             <a:r>
-              <a:rPr lang="en-SG" sz="1200" b="1" i="0" dirty="0">
+              <a:rPr lang="en-SG" sz="1150" b="1" i="0" dirty="0">
                 <a:solidFill>
                   <a:srgbClr val="69DECC"/>
                 </a:solidFill>
                 <a:latin typeface="Arial"/>
                 <a:cs typeface="Arial"/>
               </a:rPr>
-              <a:t>Changed</a:t>
-            </a:r>
-          </a:p>
-        </p:txBody>
-      </p:sp>
-      <p:sp>
-        <p:nvSpPr>
-          <p:cNvPr id="23" name="Text line"/>
+              <a:t>Assumptions</a:t>
+            </a:r>
+          </a:p>
+        </p:txBody>
+      </p:sp>
+      <p:sp>
+        <p:nvSpPr>
+          <p:cNvPr id="26" name="Text line"/>
           <p:cNvSpPr/>
           <p:nvPr/>
         </p:nvSpPr>
         <p:spPr>
           <a:xfrm>
-            <a:off x="8778240" y="3438144"/>
-            <a:ext cx="1433322" cy="54864"/>
+            <a:off x="8778240" y="3771900"/>
+            <a:ext cx="2084832" cy="54864"/>
           </a:xfrm>
           <a:prstGeom prst="roundRect">
             <a:avLst>
@@ -16401,14 +16495,14 @@
       </p:sp>
       <p:sp>
         <p:nvSpPr>
-          <p:cNvPr id="24" name="Field"/>
+          <p:cNvPr id="27" name="Field"/>
           <p:cNvSpPr txBox="1"/>
           <p:nvPr/>
         </p:nvSpPr>
         <p:spPr>
           <a:xfrm>
-            <a:off x="6519672" y="3611880"/>
-            <a:ext cx="2194560" cy="237744"/>
+            <a:off x="6519672" y="3895344"/>
+            <a:ext cx="2194560" cy="182880"/>
           </a:xfrm>
           <a:prstGeom prst="rect">
             <a:avLst/>
@@ -16437,28 +16531,28 @@
               <a:buNone/>
             </a:pPr>
             <a:r>
-              <a:rPr lang="en-SG" sz="1200" b="1" i="0" dirty="0">
+              <a:rPr lang="en-SG" sz="1150" b="1" i="0" dirty="0">
                 <a:solidFill>
                   <a:srgbClr val="69DECC"/>
                 </a:solidFill>
                 <a:latin typeface="Arial"/>
                 <a:cs typeface="Arial"/>
               </a:rPr>
-              <a:t>Checks</a:t>
-            </a:r>
-          </a:p>
-        </p:txBody>
-      </p:sp>
-      <p:sp>
-        <p:nvSpPr>
-          <p:cNvPr id="25" name="Text line"/>
+              <a:t>Untrusted content seen</a:t>
+            </a:r>
+          </a:p>
+        </p:txBody>
+      </p:sp>
+      <p:sp>
+        <p:nvSpPr>
+          <p:cNvPr id="28" name="Text line"/>
           <p:cNvSpPr/>
           <p:nvPr/>
         </p:nvSpPr>
         <p:spPr>
           <a:xfrm>
-            <a:off x="8778240" y="3703320"/>
-            <a:ext cx="2475738" cy="54864"/>
+            <a:off x="8778240" y="3959352"/>
+            <a:ext cx="1303020" cy="54864"/>
           </a:xfrm>
           <a:prstGeom prst="roundRect">
             <a:avLst>
@@ -16475,14 +16569,14 @@
       </p:sp>
       <p:sp>
         <p:nvSpPr>
-          <p:cNvPr id="26" name="Field"/>
+          <p:cNvPr id="29" name="Label"/>
           <p:cNvSpPr txBox="1"/>
           <p:nvPr/>
         </p:nvSpPr>
         <p:spPr>
           <a:xfrm>
-            <a:off x="6519672" y="3877056"/>
-            <a:ext cx="2194560" cy="237744"/>
+            <a:off x="548640" y="4279392"/>
+            <a:ext cx="11091672" cy="274320"/>
           </a:xfrm>
           <a:prstGeom prst="rect">
             <a:avLst/>
@@ -16511,258 +16605,164 @@
               <a:buNone/>
             </a:pPr>
             <a:r>
-              <a:rPr lang="en-SG" sz="1200" b="1" i="0" dirty="0">
-                <a:solidFill>
-                  <a:srgbClr val="69DECC"/>
-                </a:solidFill>
-                <a:latin typeface="Arial"/>
-                <a:cs typeface="Arial"/>
-              </a:rPr>
-              <a:t>Decisions needed</a:t>
-            </a:r>
-          </a:p>
-        </p:txBody>
-      </p:sp>
-      <p:sp>
-        <p:nvSpPr>
-          <p:cNvPr id="27" name="Text line"/>
+              <a:rPr lang="en-SG" sz="1200" b="1" i="0" spc="100" dirty="0">
+                <a:solidFill>
+                  <a:srgbClr val="FFC36A"/>
+                </a:solidFill>
+                <a:latin typeface="Arial"/>
+                <a:cs typeface="Arial"/>
+              </a:rPr>
+              <a:t>SAME WORD LIMIT, BUT THE FORMAT CAN CHANGE WHAT THE WRITER INCLUDES</a:t>
+            </a:r>
+          </a:p>
+        </p:txBody>
+      </p:sp>
+      <p:sp>
+        <p:nvSpPr>
+          <p:cNvPr id="30" name="Why summary"/>
           <p:cNvSpPr/>
           <p:nvPr/>
         </p:nvSpPr>
         <p:spPr>
           <a:xfrm>
-            <a:off x="8778240" y="3968496"/>
-            <a:ext cx="1563624" cy="54864"/>
+            <a:off x="548640" y="4617720"/>
+            <a:ext cx="5349240" cy="731520"/>
           </a:xfrm>
           <a:prstGeom prst="roundRect">
             <a:avLst>
-              <a:gd name="adj" fmla="val 50000"/>
+              <a:gd name="adj" fmla="val 10000"/>
             </a:avLst>
           </a:prstGeom>
           <a:solidFill>
-            <a:srgbClr val="5A6B86"/>
+            <a:srgbClr val="24334B"/>
           </a:solidFill>
           <a:ln>
             <a:noFill/>
           </a:ln>
         </p:spPr>
-      </p:sp>
-      <p:sp>
-        <p:nvSpPr>
-          <p:cNvPr id="28" name="Field"/>
-          <p:cNvSpPr txBox="1"/>
-          <p:nvPr/>
-        </p:nvSpPr>
-        <p:spPr>
-          <a:xfrm>
-            <a:off x="6519672" y="4142232"/>
-            <a:ext cx="2194560" cy="237744"/>
-          </a:xfrm>
-          <a:prstGeom prst="rect">
-            <a:avLst/>
-          </a:prstGeom>
-          <a:noFill/>
-          <a:ln>
-            <a:noFill/>
-          </a:ln>
-        </p:spPr>
-        <p:txBody>
-          <a:bodyPr vert="horz" wrap="square" lIns="0" tIns="0" rIns="0" bIns="0" rtlCol="0" anchor="ctr">
+        <p:txBody>
+          <a:bodyPr vert="horz" wrap="square" lIns="228600" tIns="45720" rIns="182880" bIns="45720" rtlCol="0" anchor="ctr">
             <a:noAutofit/>
           </a:bodyPr>
           <a:lstStyle/>
           <a:p>
             <a:pPr marL="0" indent="0" algn="l">
               <a:lnSpc>
-                <a:spcPct val="100000"/>
-              </a:lnSpc>
-              <a:spcBef>
-                <a:spcPts val="0"/>
-              </a:spcBef>
-              <a:spcAft>
-                <a:spcPts val="0"/>
-              </a:spcAft>
-              <a:buNone/>
-            </a:pPr>
-            <a:r>
-              <a:rPr lang="en-SG" sz="1200" b="1" i="0" dirty="0">
-                <a:solidFill>
-                  <a:srgbClr val="69DECC"/>
-                </a:solidFill>
-                <a:latin typeface="Arial"/>
-                <a:cs typeface="Arial"/>
-              </a:rPr>
-              <a:t>Assumptions</a:t>
-            </a:r>
-          </a:p>
-        </p:txBody>
-      </p:sp>
-      <p:sp>
-        <p:nvSpPr>
-          <p:cNvPr id="29" name="Text line"/>
+                <a:spcPct val="105000"/>
+              </a:lnSpc>
+              <a:spcBef>
+                <a:spcPts val="0"/>
+              </a:spcBef>
+              <a:spcAft>
+                <a:spcPts val="0"/>
+              </a:spcAft>
+              <a:buNone/>
+            </a:pPr>
+            <a:r>
+              <a:rPr lang="en-SG" sz="1500" b="1" i="0" dirty="0">
+                <a:solidFill>
+                  <a:srgbClr val="B9C4D5"/>
+                </a:solidFill>
+                <a:latin typeface="Arial"/>
+                <a:cs typeface="Arial"/>
+              </a:rPr>
+              <a:t>A summary could help: </a:t>
+            </a:r>
+            <a:r>
+              <a:rPr lang="en-SG" sz="1500" b="0" i="0" dirty="0">
+                <a:solidFill>
+                  <a:srgbClr val="F5F3EB"/>
+                </a:solidFill>
+                <a:latin typeface="Arial"/>
+                <a:cs typeface="Arial"/>
+              </a:rPr>
+              <a:t>no words go on labels, leaving room to explain why.</a:t>
+            </a:r>
+          </a:p>
+        </p:txBody>
+      </p:sp>
+      <p:sp>
+        <p:nvSpPr>
+          <p:cNvPr id="31" name="Why checklist"/>
           <p:cNvSpPr/>
           <p:nvPr/>
         </p:nvSpPr>
         <p:spPr>
           <a:xfrm>
-            <a:off x="8778240" y="4233672"/>
-            <a:ext cx="2084832" cy="54864"/>
+            <a:off x="6291072" y="4617720"/>
+            <a:ext cx="5349240" cy="731520"/>
           </a:xfrm>
           <a:prstGeom prst="roundRect">
             <a:avLst>
-              <a:gd name="adj" fmla="val 50000"/>
+              <a:gd name="adj" fmla="val 10000"/>
             </a:avLst>
           </a:prstGeom>
           <a:solidFill>
-            <a:srgbClr val="5A6B86"/>
+            <a:srgbClr val="24334B"/>
           </a:solidFill>
           <a:ln>
             <a:noFill/>
           </a:ln>
         </p:spPr>
-      </p:sp>
-      <p:sp>
-        <p:nvSpPr>
-          <p:cNvPr id="30" name="Field"/>
-          <p:cNvSpPr txBox="1"/>
-          <p:nvPr/>
-        </p:nvSpPr>
-        <p:spPr>
-          <a:xfrm>
-            <a:off x="6519672" y="4407408"/>
-            <a:ext cx="2194560" cy="237744"/>
-          </a:xfrm>
-          <a:prstGeom prst="rect">
-            <a:avLst/>
-          </a:prstGeom>
-          <a:noFill/>
-          <a:ln>
-            <a:noFill/>
-          </a:ln>
-        </p:spPr>
-        <p:txBody>
-          <a:bodyPr vert="horz" wrap="square" lIns="0" tIns="0" rIns="0" bIns="0" rtlCol="0" anchor="ctr">
+        <p:txBody>
+          <a:bodyPr vert="horz" wrap="square" lIns="228600" tIns="45720" rIns="182880" bIns="45720" rtlCol="0" anchor="ctr">
             <a:noAutofit/>
           </a:bodyPr>
           <a:lstStyle/>
           <a:p>
             <a:pPr marL="0" indent="0" algn="l">
               <a:lnSpc>
-                <a:spcPct val="100000"/>
-              </a:lnSpc>
-              <a:spcBef>
-                <a:spcPts val="0"/>
-              </a:spcBef>
-              <a:spcAft>
-                <a:spcPts val="0"/>
-              </a:spcAft>
-              <a:buNone/>
-            </a:pPr>
-            <a:r>
-              <a:rPr lang="en-SG" sz="1200" b="1" i="0" dirty="0">
+                <a:spcPct val="105000"/>
+              </a:lnSpc>
+              <a:spcBef>
+                <a:spcPts val="0"/>
+              </a:spcBef>
+              <a:spcAft>
+                <a:spcPts val="0"/>
+              </a:spcAft>
+              <a:buNone/>
+            </a:pPr>
+            <a:r>
+              <a:rPr lang="en-SG" sz="1500" b="1" i="0" dirty="0">
                 <a:solidFill>
                   <a:srgbClr val="69DECC"/>
                 </a:solidFill>
                 <a:latin typeface="Arial"/>
                 <a:cs typeface="Arial"/>
               </a:rPr>
-              <a:t>Untrusted content seen</a:t>
-            </a:r>
-          </a:p>
-        </p:txBody>
-      </p:sp>
-      <p:sp>
-        <p:nvSpPr>
-          <p:cNvPr id="31" name="Text line"/>
+              <a:t>A checklist could help: </a:t>
+            </a:r>
+            <a:r>
+              <a:rPr lang="en-SG" sz="1500" b="0" i="0" dirty="0">
+                <a:solidFill>
+                  <a:srgbClr val="F5F3EB"/>
+                </a:solidFill>
+                <a:latin typeface="Arial"/>
+                <a:cs typeface="Arial"/>
+              </a:rPr>
+              <a:t>each field reminds the writer to cover that topic.</a:t>
+            </a:r>
+          </a:p>
+        </p:txBody>
+      </p:sp>
+      <p:sp>
+        <p:nvSpPr>
+          <p:cNvPr id="32" name="Measure"/>
           <p:cNvSpPr/>
           <p:nvPr/>
         </p:nvSpPr>
         <p:spPr>
           <a:xfrm>
-            <a:off x="8778240" y="4498848"/>
-            <a:ext cx="1303020" cy="54864"/>
+            <a:off x="548640" y="5486400"/>
+            <a:ext cx="11091672" cy="621792"/>
           </a:xfrm>
           <a:prstGeom prst="roundRect">
             <a:avLst>
-              <a:gd name="adj" fmla="val 50000"/>
+              <a:gd name="adj" fmla="val 11764"/>
             </a:avLst>
           </a:prstGeom>
           <a:solidFill>
-            <a:srgbClr val="5A6B86"/>
-          </a:solidFill>
-          <a:ln>
-            <a:noFill/>
-          </a:ln>
-        </p:spPr>
-      </p:sp>
-      <p:sp>
-        <p:nvSpPr>
-          <p:cNvPr id="32" name="Same inputs"/>
-          <p:cNvSpPr txBox="1"/>
-          <p:nvPr/>
-        </p:nvSpPr>
-        <p:spPr>
-          <a:xfrm>
-            <a:off x="548640" y="4956048"/>
-            <a:ext cx="11091672" cy="411480"/>
-          </a:xfrm>
-          <a:prstGeom prst="rect">
-            <a:avLst/>
-          </a:prstGeom>
-          <a:noFill/>
-          <a:ln>
-            <a:noFill/>
-          </a:ln>
-        </p:spPr>
-        <p:txBody>
-          <a:bodyPr vert="horz" wrap="square" lIns="0" tIns="0" rIns="0" bIns="0" rtlCol="0" anchor="ctr">
-            <a:noAutofit/>
-          </a:bodyPr>
-          <a:lstStyle/>
-          <a:p>
-            <a:pPr marL="0" indent="0" algn="l">
-              <a:lnSpc>
-                <a:spcPct val="100000"/>
-              </a:lnSpc>
-              <a:spcBef>
-                <a:spcPts val="0"/>
-              </a:spcBef>
-              <a:spcAft>
-                <a:spcPts val="0"/>
-              </a:spcAft>
-              <a:buNone/>
-            </a:pPr>
-            <a:r>
-              <a:rPr lang="en-SG" sz="1700" b="0" i="0" dirty="0">
-                <a:solidFill>
-                  <a:srgbClr val="D6DDE8"/>
-                </a:solidFill>
-                <a:latin typeface="Arial"/>
-                <a:cs typeface="Arial"/>
-              </a:rPr>
-              <a:t>Both formats get the same instructions, the same message history and the same 200-word limit.</a:t>
-            </a:r>
-          </a:p>
-        </p:txBody>
-      </p:sp>
-      <p:sp>
-        <p:nvSpPr>
-          <p:cNvPr id="33" name="Measure"/>
-          <p:cNvSpPr/>
-          <p:nvPr/>
-        </p:nvSpPr>
-        <p:spPr>
-          <a:xfrm>
-            <a:off x="548640" y="5468112"/>
-            <a:ext cx="11091672" cy="640080"/>
-          </a:xfrm>
-          <a:prstGeom prst="roundRect">
-            <a:avLst>
-              <a:gd name="adj" fmla="val 11428"/>
-            </a:avLst>
-          </a:prstGeom>
-          <a:solidFill>
-            <a:srgbClr val="24334B"/>
+            <a:srgbClr val="1B2940"/>
           </a:solidFill>
           <a:ln>
             <a:noFill/>
@@ -16934,7 +16934,7 @@
                 <a:latin typeface="Arial"/>
                 <a:cs typeface="Arial"/>
               </a:rPr>
-              <a:t>The task: fix five bugs in Deskmate’s LLM health check</a:t>
+              <a:t>The task: fix 5 bugs in Deskmate’s LLM health check</a:t>
             </a:r>
           </a:p>
         </p:txBody>
@@ -16984,7 +16984,7 @@
                 <a:latin typeface="Arial"/>
                 <a:cs typeface="Arial"/>
               </a:rPr>
-              <a:t>First, a coding agent did a real MP3 task. Deskmate’s health check tests whether our app can reach its LLM provider, and its starting code had five bugs.</a:t>
+              <a:t>First, a coding agent did a real MP3 task. Deskmate’s health check tests whether our app can reach the SoC LLM provider, and its starting code had 5 bugs.</a:t>
             </a:r>
           </a:p>
         </p:txBody>
@@ -17166,7 +17166,7 @@
                 <a:latin typeface="Arial"/>
                 <a:cs typeface="Arial"/>
               </a:rPr>
-              <a:t>LLM provider</a:t>
+              <a:t>SoC LLM provider</a:t>
             </a:r>
           </a:p>
           <a:p>
@@ -17384,7 +17384,7 @@
                 <a:latin typeface="Arial"/>
                 <a:cs typeface="Arial"/>
               </a:rPr>
-              <a:t>FIVE BUGS IN THE STARTING CODE</a:t>
+              <a:t>5 BUGS IN THE STARTING CODE</a:t>
             </a:r>
           </a:p>
         </p:txBody>
@@ -18095,7 +18095,7 @@
       </p:sp>
       <p:sp>
         <p:nvSpPr>
-          <p:cNvPr id="29" name="Bug 5" descr="Bug 5: Cut-off replies. Crash the check instead of counting as a failure."/>
+          <p:cNvPr id="29" name="Bug 5" descr="Bug 5: Partial replies. A network reply cut off mid-transfer crashes the check."/>
           <p:cNvSpPr/>
           <p:nvPr/>
         </p:nvSpPr>
@@ -18214,7 +18214,7 @@
                 <a:latin typeface="Arial"/>
                 <a:cs typeface="Arial"/>
               </a:rPr>
-              <a:t>Cut-off replies</a:t>
+              <a:t>Partial replies</a:t>
             </a:r>
           </a:p>
         </p:txBody>
@@ -18264,7 +18264,7 @@
                 <a:latin typeface="Arial"/>
                 <a:cs typeface="Arial"/>
               </a:rPr>
-              <a:t>Crash the check instead of counting as a failure</a:t>
+              <a:t>A network reply cut off mid-transfer crashes the check</a:t>
             </a:r>
           </a:p>
         </p:txBody>
@@ -18314,7 +18314,7 @@
                 <a:latin typeface="Arial"/>
                 <a:cs typeface="Arial"/>
               </a:rPr>
-              <a:t>The fix also had to keep every other documented rule, such as which replies count as a success.</a:t>
+              <a:t>The fix also had to follow all other documented rules, such as which replies count as a success.</a:t>
             </a:r>
           </a:p>
         </p:txBody>
@@ -18444,7 +18444,7 @@
                 <a:latin typeface="Arial"/>
                 <a:cs typeface="Arial"/>
               </a:rPr>
-              <a:t>Three agents pass the work along</a:t>
+              <a:t>3 agents pass the work along</a:t>
             </a:r>
           </a:p>
         </p:txBody>
@@ -18494,7 +18494,7 @@
                 <a:latin typeface="Arial"/>
                 <a:cs typeface="Arial"/>
               </a:rPr>
-              <a:t>The coding agent’s message history goes to two handoff agents, one per format. A fresh receiving agent then answers six questions using only one handoff.</a:t>
+              <a:t>The coding agent’s message history goes to 2 handoff agents, one per format. A fresh receiving agent then answers 6 questions using only one handoff.</a:t>
             </a:r>
           </a:p>
         </p:txBody>
@@ -18707,12 +18707,12 @@
           </a:ln>
         </p:spPr>
         <p:txBody>
-          <a:bodyPr vert="horz" wrap="square" lIns="146304" tIns="146304" rIns="109728" bIns="91440" rtlCol="0" anchor="t">
+          <a:bodyPr vert="horz" wrap="square" lIns="146304" tIns="91440" rIns="109728" bIns="91440" rtlCol="0" anchor="ctr">
             <a:noAutofit/>
           </a:bodyPr>
           <a:lstStyle/>
           <a:p>
-            <a:pPr marL="0" indent="0" algn="l">
+            <a:pPr marL="0" indent="0" algn="ctr">
               <a:lnSpc>
                 <a:spcPct val="100000"/>
               </a:lnSpc>
@@ -18720,7 +18720,7 @@
                 <a:spcPts val="0"/>
               </a:spcBef>
               <a:spcAft>
-                <a:spcPts val="400"/>
+                <a:spcPts val="0"/>
               </a:spcAft>
               <a:buNone/>
             </a:pPr>
@@ -18735,131 +18735,11 @@
               <a:t>Message history</a:t>
             </a:r>
           </a:p>
-          <a:p>
-            <a:pPr marL="0" indent="0" algn="l">
-              <a:lnSpc>
-                <a:spcPct val="100000"/>
-              </a:lnSpc>
-              <a:spcBef>
-                <a:spcPts val="0"/>
-              </a:spcBef>
-              <a:spcAft>
-                <a:spcPts val="0"/>
-              </a:spcAft>
-              <a:buNone/>
-            </a:pPr>
-            <a:r>
-              <a:rPr lang="en-SG" sz="1200" b="0" i="0" dirty="0">
-                <a:solidFill>
-                  <a:srgbClr val="B9C4D5"/>
-                </a:solidFill>
-                <a:latin typeface="Arial"/>
-                <a:cs typeface="Arial"/>
-              </a:rPr>
-              <a:t>about 3,500 words</a:t>
-            </a:r>
-          </a:p>
-        </p:txBody>
-      </p:sp>
-      <p:sp>
-        <p:nvSpPr>
-          <p:cNvPr id="9" name="Text line"/>
-          <p:cNvSpPr/>
-          <p:nvPr/>
-        </p:nvSpPr>
-        <p:spPr>
-          <a:xfrm>
-            <a:off x="3136392" y="3657600"/>
-            <a:ext cx="1371600" cy="54864"/>
-          </a:xfrm>
-          <a:prstGeom prst="roundRect">
-            <a:avLst>
-              <a:gd name="adj" fmla="val 50000"/>
-            </a:avLst>
-          </a:prstGeom>
-          <a:solidFill>
-            <a:srgbClr val="5A6B86"/>
-          </a:solidFill>
-          <a:ln>
-            <a:noFill/>
-          </a:ln>
-        </p:spPr>
-      </p:sp>
-      <p:sp>
-        <p:nvSpPr>
-          <p:cNvPr id="10" name="Text line"/>
-          <p:cNvSpPr/>
-          <p:nvPr/>
-        </p:nvSpPr>
-        <p:spPr>
-          <a:xfrm>
-            <a:off x="3136392" y="3813048"/>
-            <a:ext cx="1261872" cy="54864"/>
-          </a:xfrm>
-          <a:prstGeom prst="roundRect">
-            <a:avLst>
-              <a:gd name="adj" fmla="val 50000"/>
-            </a:avLst>
-          </a:prstGeom>
-          <a:solidFill>
-            <a:srgbClr val="5A6B86"/>
-          </a:solidFill>
-          <a:ln>
-            <a:noFill/>
-          </a:ln>
-        </p:spPr>
-      </p:sp>
-      <p:sp>
-        <p:nvSpPr>
-          <p:cNvPr id="11" name="Text line"/>
-          <p:cNvSpPr/>
-          <p:nvPr/>
-        </p:nvSpPr>
-        <p:spPr>
-          <a:xfrm>
-            <a:off x="3136392" y="3968496"/>
-            <a:ext cx="1330452" cy="54864"/>
-          </a:xfrm>
-          <a:prstGeom prst="roundRect">
-            <a:avLst>
-              <a:gd name="adj" fmla="val 50000"/>
-            </a:avLst>
-          </a:prstGeom>
-          <a:solidFill>
-            <a:srgbClr val="5A6B86"/>
-          </a:solidFill>
-          <a:ln>
-            <a:noFill/>
-          </a:ln>
-        </p:spPr>
-      </p:sp>
-      <p:sp>
-        <p:nvSpPr>
-          <p:cNvPr id="12" name="Text line"/>
-          <p:cNvSpPr/>
-          <p:nvPr/>
-        </p:nvSpPr>
-        <p:spPr>
-          <a:xfrm>
-            <a:off x="3136392" y="4123944"/>
-            <a:ext cx="1165860" cy="54864"/>
-          </a:xfrm>
-          <a:prstGeom prst="roundRect">
-            <a:avLst>
-              <a:gd name="adj" fmla="val 50000"/>
-            </a:avLst>
-          </a:prstGeom>
-          <a:solidFill>
-            <a:srgbClr val="5A6B86"/>
-          </a:solidFill>
-          <a:ln>
-            <a:noFill/>
-          </a:ln>
-        </p:spPr>
+        </p:txBody>
       </p:sp>
       <p:cxnSp>
         <p:nvCxnSpPr>
-          <p:cNvPr id="13" name="Arrow"/>
+          <p:cNvPr id="9" name="Arrow"/>
           <p:cNvCxnSpPr/>
           <p:nvPr/>
         </p:nvCxnSpPr>
@@ -18881,7 +18761,7 @@
       </p:cxnSp>
       <p:sp>
         <p:nvSpPr>
-          <p:cNvPr id="14" name="Handoff agent"/>
+          <p:cNvPr id="10" name="Handoff agent"/>
           <p:cNvSpPr/>
           <p:nvPr/>
         </p:nvSpPr>
@@ -18962,7 +18842,7 @@
                 <a:latin typeface="Arial"/>
                 <a:cs typeface="Arial"/>
               </a:rPr>
-              <a:t>writes a free-form summary</a:t>
+              <a:t>summarises the history</a:t>
             </a:r>
           </a:p>
           <a:p>
@@ -18993,7 +18873,7 @@
       </p:sp>
       <p:cxnSp>
         <p:nvCxnSpPr>
-          <p:cNvPr id="15" name="Arrow"/>
+          <p:cNvPr id="11" name="Arrow"/>
           <p:cNvCxnSpPr/>
           <p:nvPr/>
         </p:nvCxnSpPr>
@@ -19015,7 +18895,7 @@
       </p:cxnSp>
       <p:sp>
         <p:nvSpPr>
-          <p:cNvPr id="16" name="Handoff"/>
+          <p:cNvPr id="12" name="Handoff"/>
           <p:cNvSpPr/>
           <p:nvPr/>
         </p:nvSpPr>
@@ -19036,106 +18916,40 @@
             <a:noFill/>
           </a:ln>
         </p:spPr>
-      </p:sp>
-      <p:sp>
-        <p:nvSpPr>
-          <p:cNvPr id="17" name="Text line"/>
-          <p:cNvSpPr/>
-          <p:nvPr/>
-        </p:nvSpPr>
-        <p:spPr>
-          <a:xfrm>
-            <a:off x="7863840" y="2624328"/>
-            <a:ext cx="960120" cy="54864"/>
-          </a:xfrm>
-          <a:prstGeom prst="roundRect">
-            <a:avLst>
-              <a:gd name="adj" fmla="val 50000"/>
-            </a:avLst>
-          </a:prstGeom>
-          <a:solidFill>
-            <a:srgbClr val="5A6B86"/>
-          </a:solidFill>
-          <a:ln>
-            <a:noFill/>
-          </a:ln>
-        </p:spPr>
-      </p:sp>
-      <p:sp>
-        <p:nvSpPr>
-          <p:cNvPr id="18" name="Text line"/>
-          <p:cNvSpPr/>
-          <p:nvPr/>
-        </p:nvSpPr>
-        <p:spPr>
-          <a:xfrm>
-            <a:off x="7863840" y="2761488"/>
-            <a:ext cx="883310" cy="54864"/>
-          </a:xfrm>
-          <a:prstGeom prst="roundRect">
-            <a:avLst>
-              <a:gd name="adj" fmla="val 50000"/>
-            </a:avLst>
-          </a:prstGeom>
-          <a:solidFill>
-            <a:srgbClr val="5A6B86"/>
-          </a:solidFill>
-          <a:ln>
-            <a:noFill/>
-          </a:ln>
-        </p:spPr>
-      </p:sp>
-      <p:sp>
-        <p:nvSpPr>
-          <p:cNvPr id="19" name="Text line"/>
-          <p:cNvSpPr/>
-          <p:nvPr/>
-        </p:nvSpPr>
-        <p:spPr>
-          <a:xfrm>
-            <a:off x="7863840" y="2898648"/>
-            <a:ext cx="931316" cy="54864"/>
-          </a:xfrm>
-          <a:prstGeom prst="roundRect">
-            <a:avLst>
-              <a:gd name="adj" fmla="val 50000"/>
-            </a:avLst>
-          </a:prstGeom>
-          <a:solidFill>
-            <a:srgbClr val="5A6B86"/>
-          </a:solidFill>
-          <a:ln>
-            <a:noFill/>
-          </a:ln>
-        </p:spPr>
-      </p:sp>
-      <p:sp>
-        <p:nvSpPr>
-          <p:cNvPr id="20" name="Text line"/>
-          <p:cNvSpPr/>
-          <p:nvPr/>
-        </p:nvSpPr>
-        <p:spPr>
-          <a:xfrm>
-            <a:off x="7863840" y="3035808"/>
-            <a:ext cx="816102" cy="54864"/>
-          </a:xfrm>
-          <a:prstGeom prst="roundRect">
-            <a:avLst>
-              <a:gd name="adj" fmla="val 50000"/>
-            </a:avLst>
-          </a:prstGeom>
-          <a:solidFill>
-            <a:srgbClr val="5A6B86"/>
-          </a:solidFill>
-          <a:ln>
-            <a:noFill/>
-          </a:ln>
-        </p:spPr>
+        <p:txBody>
+          <a:bodyPr vert="horz" wrap="square" lIns="73152" tIns="36576" rIns="73152" bIns="36576" rtlCol="0" anchor="ctr">
+            <a:noAutofit/>
+          </a:bodyPr>
+          <a:lstStyle/>
+          <a:p>
+            <a:pPr marL="0" indent="0" algn="ctr">
+              <a:lnSpc>
+                <a:spcPct val="100000"/>
+              </a:lnSpc>
+              <a:spcBef>
+                <a:spcPts val="0"/>
+              </a:spcBef>
+              <a:spcAft>
+                <a:spcPts val="0"/>
+              </a:spcAft>
+              <a:buNone/>
+            </a:pPr>
+            <a:r>
+              <a:rPr lang="en-SG" sz="1300" b="1" i="0" dirty="0">
+                <a:solidFill>
+                  <a:srgbClr val="F5F3EB"/>
+                </a:solidFill>
+                <a:latin typeface="Arial"/>
+                <a:cs typeface="Arial"/>
+              </a:rPr>
+              <a:t>Free-form summary</a:t>
+            </a:r>
+          </a:p>
+        </p:txBody>
       </p:sp>
       <p:cxnSp>
         <p:nvCxnSpPr>
-          <p:cNvPr id="21" name="Arrow"/>
+          <p:cNvPr id="13" name="Arrow"/>
           <p:cNvCxnSpPr/>
           <p:nvPr/>
         </p:nvCxnSpPr>
@@ -19157,7 +18971,7 @@
       </p:cxnSp>
       <p:sp>
         <p:nvSpPr>
-          <p:cNvPr id="22" name="Receiving agent"/>
+          <p:cNvPr id="14" name="Receiving agent"/>
           <p:cNvSpPr/>
           <p:nvPr/>
         </p:nvSpPr>
@@ -19269,7 +19083,7 @@
       </p:sp>
       <p:cxnSp>
         <p:nvCxnSpPr>
-          <p:cNvPr id="23" name="Arrow"/>
+          <p:cNvPr id="15" name="Arrow"/>
           <p:cNvCxnSpPr/>
           <p:nvPr/>
         </p:nvCxnSpPr>
@@ -19291,7 +19105,7 @@
       </p:cxnSp>
       <p:sp>
         <p:nvSpPr>
-          <p:cNvPr id="24" name="Handoff agent"/>
+          <p:cNvPr id="16" name="Handoff agent"/>
           <p:cNvSpPr/>
           <p:nvPr/>
         </p:nvSpPr>
@@ -19372,7 +19186,7 @@
                 <a:latin typeface="Arial"/>
                 <a:cs typeface="Arial"/>
               </a:rPr>
-              <a:t>writes a checklist</a:t>
+              <a:t>summarises the history</a:t>
             </a:r>
           </a:p>
           <a:p>
@@ -19403,7 +19217,7 @@
       </p:sp>
       <p:cxnSp>
         <p:nvCxnSpPr>
-          <p:cNvPr id="25" name="Arrow"/>
+          <p:cNvPr id="17" name="Arrow"/>
           <p:cNvCxnSpPr/>
           <p:nvPr/>
         </p:nvCxnSpPr>
@@ -19425,7 +19239,7 @@
       </p:cxnSp>
       <p:sp>
         <p:nvSpPr>
-          <p:cNvPr id="26" name="Handoff"/>
+          <p:cNvPr id="18" name="Handoff"/>
           <p:cNvSpPr/>
           <p:nvPr/>
         </p:nvSpPr>
@@ -19446,106 +19260,40 @@
             <a:noFill/>
           </a:ln>
         </p:spPr>
-      </p:sp>
-      <p:sp>
-        <p:nvSpPr>
-          <p:cNvPr id="27" name="Text line"/>
-          <p:cNvSpPr/>
-          <p:nvPr/>
-        </p:nvSpPr>
-        <p:spPr>
-          <a:xfrm>
-            <a:off x="7863840" y="4270248"/>
-            <a:ext cx="960120" cy="54864"/>
-          </a:xfrm>
-          <a:prstGeom prst="roundRect">
-            <a:avLst>
-              <a:gd name="adj" fmla="val 50000"/>
-            </a:avLst>
-          </a:prstGeom>
-          <a:solidFill>
-            <a:srgbClr val="5A6B86"/>
-          </a:solidFill>
-          <a:ln>
-            <a:noFill/>
-          </a:ln>
-        </p:spPr>
-      </p:sp>
-      <p:sp>
-        <p:nvSpPr>
-          <p:cNvPr id="28" name="Text line"/>
-          <p:cNvSpPr/>
-          <p:nvPr/>
-        </p:nvSpPr>
-        <p:spPr>
-          <a:xfrm>
-            <a:off x="7863840" y="4407408"/>
-            <a:ext cx="883310" cy="54864"/>
-          </a:xfrm>
-          <a:prstGeom prst="roundRect">
-            <a:avLst>
-              <a:gd name="adj" fmla="val 50000"/>
-            </a:avLst>
-          </a:prstGeom>
-          <a:solidFill>
-            <a:srgbClr val="5A6B86"/>
-          </a:solidFill>
-          <a:ln>
-            <a:noFill/>
-          </a:ln>
-        </p:spPr>
-      </p:sp>
-      <p:sp>
-        <p:nvSpPr>
-          <p:cNvPr id="29" name="Text line"/>
-          <p:cNvSpPr/>
-          <p:nvPr/>
-        </p:nvSpPr>
-        <p:spPr>
-          <a:xfrm>
-            <a:off x="7863840" y="4544568"/>
-            <a:ext cx="931316" cy="54864"/>
-          </a:xfrm>
-          <a:prstGeom prst="roundRect">
-            <a:avLst>
-              <a:gd name="adj" fmla="val 50000"/>
-            </a:avLst>
-          </a:prstGeom>
-          <a:solidFill>
-            <a:srgbClr val="5A6B86"/>
-          </a:solidFill>
-          <a:ln>
-            <a:noFill/>
-          </a:ln>
-        </p:spPr>
-      </p:sp>
-      <p:sp>
-        <p:nvSpPr>
-          <p:cNvPr id="30" name="Text line"/>
-          <p:cNvSpPr/>
-          <p:nvPr/>
-        </p:nvSpPr>
-        <p:spPr>
-          <a:xfrm>
-            <a:off x="7863840" y="4681728"/>
-            <a:ext cx="816102" cy="54864"/>
-          </a:xfrm>
-          <a:prstGeom prst="roundRect">
-            <a:avLst>
-              <a:gd name="adj" fmla="val 50000"/>
-            </a:avLst>
-          </a:prstGeom>
-          <a:solidFill>
-            <a:srgbClr val="5A6B86"/>
-          </a:solidFill>
-          <a:ln>
-            <a:noFill/>
-          </a:ln>
-        </p:spPr>
+        <p:txBody>
+          <a:bodyPr vert="horz" wrap="square" lIns="73152" tIns="36576" rIns="73152" bIns="36576" rtlCol="0" anchor="ctr">
+            <a:noAutofit/>
+          </a:bodyPr>
+          <a:lstStyle/>
+          <a:p>
+            <a:pPr marL="0" indent="0" algn="ctr">
+              <a:lnSpc>
+                <a:spcPct val="100000"/>
+              </a:lnSpc>
+              <a:spcBef>
+                <a:spcPts val="0"/>
+              </a:spcBef>
+              <a:spcAft>
+                <a:spcPts val="0"/>
+              </a:spcAft>
+              <a:buNone/>
+            </a:pPr>
+            <a:r>
+              <a:rPr lang="en-SG" sz="1300" b="1" i="0" dirty="0">
+                <a:solidFill>
+                  <a:srgbClr val="F5F3EB"/>
+                </a:solidFill>
+                <a:latin typeface="Arial"/>
+                <a:cs typeface="Arial"/>
+              </a:rPr>
+              <a:t>Checklist</a:t>
+            </a:r>
+          </a:p>
+        </p:txBody>
       </p:sp>
       <p:cxnSp>
         <p:nvCxnSpPr>
-          <p:cNvPr id="31" name="Arrow"/>
+          <p:cNvPr id="19" name="Arrow"/>
           <p:cNvCxnSpPr/>
           <p:nvPr/>
         </p:nvCxnSpPr>
@@ -19567,7 +19315,7 @@
       </p:cxnSp>
       <p:sp>
         <p:nvSpPr>
-          <p:cNvPr id="32" name="Receiving agent"/>
+          <p:cNvPr id="20" name="Receiving agent"/>
           <p:cNvSpPr/>
           <p:nvPr/>
         </p:nvSpPr>
@@ -19679,7 +19427,7 @@
       </p:sp>
       <p:sp>
         <p:nvSpPr>
-          <p:cNvPr id="33" name="Scale"/>
+          <p:cNvPr id="21" name="Scale"/>
           <p:cNvSpPr/>
           <p:nvPr/>
         </p:nvSpPr>
@@ -19940,7 +19688,7 @@
                 <a:latin typeface="Arial"/>
                 <a:cs typeface="Arial"/>
               </a:rPr>
-              <a:t>For each coding run, I wrote an answer key before its handoffs existed. It splits the six questions into expected facts, taken only from that run’s message history.</a:t>
+              <a:t>For each coding run, I wrote an answer key before its handoffs existed. It splits the 6 questions into expected facts, taken only from that specific run’s message history.</a:t>
             </a:r>
           </a:p>
         </p:txBody>
@@ -20040,7 +19788,7 @@
                 <a:latin typeface="Arial"/>
                 <a:cs typeface="Arial"/>
               </a:rPr>
-              <a:t>THE SIX QUESTIONS</a:t>
+              <a:t>THE 6 QUESTIONS</a:t>
             </a:r>
           </a:p>
         </p:txBody>
@@ -21321,14 +21069,14 @@
               <a:buNone/>
             </a:pPr>
             <a:r>
-              <a:rPr lang="en-SG" sz="1300" b="0" i="0" dirty="0">
+              <a:rPr lang="en-SG" sz="1250" b="0" i="0" dirty="0">
                 <a:solidFill>
                   <a:srgbClr val="B9C4D5"/>
                 </a:solidFill>
                 <a:latin typeface="Arial"/>
                 <a:cs typeface="Arial"/>
               </a:rPr>
-              <a:t>136 expected facts for each handoff model and format</a:t>
+              <a:t>27 or 28 facts per run: 136 across all 5 runs, for each model and format</a:t>
             </a:r>
           </a:p>
         </p:txBody>
@@ -21508,7 +21256,7 @@
                 <a:latin typeface="Arial"/>
                 <a:cs typeface="Arial"/>
               </a:rPr>
-              <a:t>No format won overall. GPT models did slightly better with free-form summaries, and Claude models with checklists. Every gap was 5 facts or fewer, out of 136.</a:t>
+              <a:t>No format won overall. GPT models did slightly better with free-form summaries, and Claude models with checklists. Every gap was 5 facts or fewer, out of 136 across all 5 runs.</a:t>
             </a:r>
           </a:p>
         </p:txBody>
@@ -21737,7 +21485,7 @@
       </p:sp>
       <p:sp>
         <p:nvSpPr>
-          <p:cNvPr id="9" name="Caution"/>
+          <p:cNvPr id="9" name="Model strength"/>
           <p:cNvSpPr/>
           <p:nvPr/>
         </p:nvSpPr>
@@ -21784,7 +21532,7 @@
                 <a:latin typeface="Arial"/>
                 <a:cs typeface="Arial"/>
               </a:rPr>
-              <a:t>Treat these gaps with care</a:t>
+              <a:t>Stronger model, higher score</a:t>
             </a:r>
           </a:p>
           <a:p>
@@ -21801,14 +21549,14 @@
               <a:buNone/>
             </a:pPr>
             <a:r>
-              <a:rPr lang="en-SG" sz="1350" b="0" i="0" dirty="0">
+              <a:rPr lang="en-SG" sz="1400" b="0" i="0" dirty="0">
                 <a:solidFill>
                   <a:srgbClr val="D6DDE8"/>
                 </a:solidFill>
                 <a:latin typeface="Arial"/>
                 <a:cs typeface="Arial"/>
               </a:rPr>
-              <a:t>9 of the 10 Claude checklists broke the 200-word limit, and two extra runs flipped Luna’s lead.</a:t>
+              <a:t>In both formats, Sol beat Luna by 11 to 14 facts, and Opus beat Sonnet by 4 facts.</a:t>
             </a:r>
           </a:p>
         </p:txBody>
@@ -22117,8 +21865,8 @@
         </p:nvSpPr>
         <p:spPr>
           <a:xfrm>
-            <a:off x="8778240" y="3154680"/>
-            <a:ext cx="2862072" cy="868680"/>
+            <a:off x="8778240" y="3108960"/>
+            <a:ext cx="2862072" cy="777240"/>
           </a:xfrm>
           <a:prstGeom prst="rect">
             <a:avLst/>
@@ -22167,12 +21915,12 @@
         </p:nvSpPr>
         <p:spPr>
           <a:xfrm>
-            <a:off x="8778240" y="4251960"/>
-            <a:ext cx="2862072" cy="1874520"/>
+            <a:off x="8778240" y="3931920"/>
+            <a:ext cx="2862072" cy="2194560"/>
           </a:xfrm>
           <a:prstGeom prst="roundRect">
             <a:avLst>
-              <a:gd name="adj" fmla="val 3902"/>
+              <a:gd name="adj" fmla="val 3333"/>
             </a:avLst>
           </a:prstGeom>
           <a:solidFill>
@@ -22196,7 +21944,7 @@
                 <a:spcPts val="0"/>
               </a:spcBef>
               <a:spcAft>
-                <a:spcPts val="400"/>
+                <a:spcPts val="500"/>
               </a:spcAft>
               <a:buNone/>
             </a:pPr>
@@ -22208,31 +21956,79 @@
                 <a:latin typeface="Arial"/>
                 <a:cs typeface="Arial"/>
               </a:rPr>
-              <a:t>Why?</a:t>
+              <a:t>Likely reasons</a:t>
             </a:r>
           </a:p>
           <a:p>
             <a:pPr marL="0" indent="0" algn="l">
               <a:lnSpc>
-                <a:spcPct val="110000"/>
-              </a:lnSpc>
-              <a:spcBef>
-                <a:spcPts val="0"/>
-              </a:spcBef>
-              <a:spcAft>
-                <a:spcPts val="0"/>
-              </a:spcAft>
-              <a:buNone/>
-            </a:pPr>
-            <a:r>
-              <a:rPr lang="en-SG" sz="1350" b="0" i="0" dirty="0">
+                <a:spcPct val="105000"/>
+              </a:lnSpc>
+              <a:spcBef>
+                <a:spcPts val="0"/>
+              </a:spcBef>
+              <a:spcAft>
+                <a:spcPts val="500"/>
+              </a:spcAft>
+              <a:buNone/>
+            </a:pPr>
+            <a:r>
+              <a:rPr lang="en-SG" sz="1300" b="0" i="0" dirty="0">
                 <a:solidFill>
                   <a:srgbClr val="D6DDE8"/>
                 </a:solidFill>
                 <a:latin typeface="Arial"/>
                 <a:cs typeface="Arial"/>
               </a:rPr>
-              <a:t>The handoffs described what the agent changed. They almost never listed the rules the check had to meet.</a:t>
+              <a:t>None of the 7 topics asked for these rules.</a:t>
+            </a:r>
+          </a:p>
+          <a:p>
+            <a:pPr marL="0" indent="0" algn="l">
+              <a:lnSpc>
+                <a:spcPct val="105000"/>
+              </a:lnSpc>
+              <a:spcBef>
+                <a:spcPts val="0"/>
+              </a:spcBef>
+              <a:spcAft>
+                <a:spcPts val="500"/>
+              </a:spcAft>
+              <a:buNone/>
+            </a:pPr>
+            <a:r>
+              <a:rPr lang="en-SG" sz="1300" b="0" i="0" dirty="0">
+                <a:solidFill>
+                  <a:srgbClr val="D6DDE8"/>
+                </a:solidFill>
+                <a:latin typeface="Arial"/>
+                <a:cs typeface="Arial"/>
+              </a:rPr>
+              <a:t>The rules weren’t among the 5 bugs, and handoffs mostly described changes.</a:t>
+            </a:r>
+          </a:p>
+          <a:p>
+            <a:pPr marL="0" indent="0" algn="l">
+              <a:lnSpc>
+                <a:spcPct val="105000"/>
+              </a:lnSpc>
+              <a:spcBef>
+                <a:spcPts val="0"/>
+              </a:spcBef>
+              <a:spcAft>
+                <a:spcPts val="0"/>
+              </a:spcAft>
+              <a:buNone/>
+            </a:pPr>
+            <a:r>
+              <a:rPr lang="en-SG" sz="1300" b="0" i="0" dirty="0">
+                <a:solidFill>
+                  <a:srgbClr val="D6DDE8"/>
+                </a:solidFill>
+                <a:latin typeface="Arial"/>
+                <a:cs typeface="Arial"/>
+              </a:rPr>
+              <a:t>Not the word limit: handoffs over 200 words left them out too.</a:t>
             </a:r>
           </a:p>
         </p:txBody>

</xml_diff>

<commit_message>
log: Record the handoff slide revisions
Document the interpretation, wording and layout corrections, and include the updated PowerPoint and PDF.
</commit_message>
<xml_diff>
--- a/experiments/agent-handoff-2026-10-19/Agent_Handoff_Results.pptx
+++ b/experiments/agent-handoff-2026-10-19/Agent_Handoff_Results.pptx
@@ -1500,7 +1500,7 @@
           <a:p>
             <a:r>
               <a:rPr lang="en-SG" dirty="0"/>
-              <a:t>The Week 9 Agent Workflow Notes template lists Goal, Current State, Decisions, Findings, Open Questions, Next Actions and Change Log. Our MP3 handoff block (AGENTS.md) has no goal or success-criteria field. Week 8's handoff skill also points towards idea 2: its deduplication feature references existing artefacts by path or URL instead of repeating them. A fair next test would also enforce the word limit, use more than one task, and use blind grading.</a:t>
+              <a:t>The Week 9 Agent Workflow Notes template lists Goal, Current State, Decisions, Findings, Open Questions, Next Actions and Change Log. Our MP3 handoff block (AGENTS.md) has no goal or success-criteria field. Week 8's handoff skill also points towards idea 2: it links to existing work by path or URL instead of repeating it. Both handoff formats almost always left out rules that the quiz asked about but the handoff prompt did not ask writers to include. This does not show that agents usually leave out unchanged requirements, or that changing the instructions would help more than changing the format. We also did not test whether the missing rules caused problems with later coding. Asking for the information the next agent needs is an idea to test. We did not test adding a field or letting the next agent look up the contract. A fair next test would ask for both changes and relevant requirements, enforce the word limit, use more than one task, and grade answers without knowing which format produced them.</a:t>
             </a:r>
           </a:p>
           <a:p>
@@ -1509,7 +1509,7 @@
           <a:p>
             <a:r>
               <a:rPr lang="en-SG" dirty="0"/>
-              <a:t>Sources: Week 9 lecture (Optimization for Long Tasks: Recall First, Structured Note Taking; Context Retrieval: Just-in-Time Retrieval); Week 8 lecture (Handoff as a Skill); AGENTS.md (Handoff).</a:t>
+              <a:t>Sources: Week 9 lecture (Optimization for Long Tasks: Recall First, Structured Note Taking; Context Retrieval: Just-in-Time Retrieval); Week 8 lecture (Handoff as a Skill); AGENTS.md (Handoff); results ZIP, original-three-histories/frozen/handoff-prompts.json and original-three-histories/frozen/questions.json.</a:t>
             </a:r>
           </a:p>
         </p:txBody>
@@ -2539,7 +2539,7 @@
           <a:p>
             <a:r>
               <a:rPr lang="en-SG" dirty="0"/>
-              <a:t>The success rules come from the probe's contract: status 200, valid UTF-8 JSON, a non-empty choices list, a non-blank message, and a body of at most 65,536 bytes. The bars pool all 40 handoffs. Reading the 40 handoff texts confirms the loss happened when the handoff was written: almost none mention these rules. The word limit does not explain the loss: the 12 handoffs over 200 words kept 2 of their 108 success-rule facts (2%), against 2 of 252 (1%) for the rest. The success rules were not among the 5 bugs, and none of the 7 prompt topics asks for them. The timeout question shows the same pattern at 45%: 35 of 40 handoffs kept the 10-second limit, but none kept the recorded reason for using one total deadline rather than a per-socket timeout.</a:t>
+              <a:t>The rules for which replies count as a success come from the probe's contract: status 200, valid UTF-8 JSON, a non-empty choices list, a non-blank message, and a body of at most 65,536 bytes. The bars cover all 40 handoffs. Almost none of the handoffs mention these rules. Both handoff prompts asked for changed files and checks. Neither asked the writer to explain which replies count as a success, but question 5 of the quiz did. We therefore cannot use this result to say that agents usually leave out unchanged requirements. These rules were also outside the five bugs being repaired. We did not try another prompt that asked for the rules, or ask the next agent to do more coding. The 12 handoffs over 200 words kept 2 of their 108 facts about these rules (2%), against 2 of 252 (1%) for the rest. Going over the limit did not ensure the rules were included, but we did not test the effect of a different word limit. For the timeout question, 45% of the expected facts survived: 35 of 40 handoffs kept the 10-second limit, but none kept the recorded reason for using one total deadline rather than a timeout for each socket operation.</a:t>
             </a:r>
           </a:p>
           <a:p>
@@ -2548,7 +2548,7 @@
           <a:p>
             <a:r>
               <a:rPr lang="en-SG" dirty="0"/>
-              <a:t>Sources: results ZIP, question-results.json, fact-scores.json, evidence/*/handoff.txt.</a:t>
+              <a:t>Sources: results ZIP, question-results.json, fact-scores.json, evidence/*/handoff.txt, original-three-histories/frozen/handoff-prompts.json and original-three-histories/frozen/questions.json.</a:t>
             </a:r>
           </a:p>
         </p:txBody>
@@ -9221,7 +9221,7 @@
                 <a:latin typeface="Arial"/>
                 <a:cs typeface="Arial"/>
               </a:rPr>
-              <a:t>The format made only small differences. What mattered more was whether the handoff had the right facts.</a:t>
+              <a:t>No format won overall. Both left out rules we hadn’t asked them to include, even though the quiz asked about them.</a:t>
             </a:r>
           </a:p>
         </p:txBody>
@@ -9325,7 +9325,7 @@
                 <a:latin typeface="Arial"/>
                 <a:cs typeface="Arial"/>
               </a:rPr>
-              <a:t>Lost information can’t be recovered. Extra information can be trimmed later.</a:t>
+              <a:t>A handoff can cover every requested topic and still leave out facts the next agent is asked about.</a:t>
             </a:r>
           </a:p>
           <a:p>
@@ -9349,7 +9349,7 @@
                 <a:latin typeface="Arial"/>
                 <a:cs typeface="Arial"/>
               </a:rPr>
-              <a:t>Our handoffs kept what the agent did, but lost the rules the work had to meet.</a:t>
+              <a:t>We haven’t tested whether adding these rules would help with later coding.</a:t>
             </a:r>
           </a:p>
         </p:txBody>
@@ -9399,7 +9399,7 @@
                 <a:latin typeface="Arial"/>
                 <a:cs typeface="Arial"/>
               </a:rPr>
-              <a:t>IDEAS TO TEST NEXT, FOR OUR MP3 WORKFLOW</a:t>
+              <a:t>POTENTIAL FOLLOW-UP EXPERIMENTS</a:t>
             </a:r>
           </a:p>
         </p:txBody>
@@ -9585,7 +9585,7 @@
                 <a:latin typeface="Arial"/>
                 <a:cs typeface="Arial"/>
               </a:rPr>
-              <a:t>the lecture’s note template starts with the Goal; our checklist has no such field.</a:t>
+              <a:t>try adding the goal and the rules the next agent needs to know.</a:t>
             </a:r>
           </a:p>
         </p:txBody>
@@ -12874,7 +12874,7 @@
                 <a:latin typeface="Arial"/>
                 <a:cs typeface="Arial"/>
               </a:rPr>
-              <a:t>A fresh copy of the same starting code, contract and 30 offline tests. All 5 repairs passed all 30 tests.</a:t>
+              <a:t>Each coding run had its own folder, with the same starting code, requirements and tests. All 5 repairs passed all 30 tests.</a:t>
             </a:r>
           </a:p>
         </p:txBody>
@@ -21686,7 +21686,7 @@
                 <a:latin typeface="Arial"/>
                 <a:cs typeface="Arial"/>
               </a:rPr>
-              <a:t>The real gap was in which facts survived</a:t>
+              <a:t>Some facts survived much better than others</a:t>
             </a:r>
           </a:p>
         </p:txBody>
@@ -21736,7 +21736,7 @@
                 <a:latin typeface="Arial"/>
                 <a:cs typeface="Arial"/>
               </a:rPr>
-              <a:t>Facts about what the agent did nearly always survived. The rules for what counts as a successful response almost never did.</a:t>
+              <a:t>The handoffs said which files changed and whether the tests passed. They almost never said which replies count as a success.</a:t>
             </a:r>
           </a:p>
         </p:txBody>
@@ -21916,7 +21916,7 @@
         <p:spPr>
           <a:xfrm>
             <a:off x="8778240" y="3931920"/>
-            <a:ext cx="2862072" cy="2194560"/>
+            <a:ext cx="2862072" cy="1524000"/>
           </a:xfrm>
           <a:prstGeom prst="roundRect">
             <a:avLst>
@@ -21956,7 +21956,7 @@
                 <a:latin typeface="Arial"/>
                 <a:cs typeface="Arial"/>
               </a:rPr>
-              <a:t>Likely reasons</a:t>
+              <a:t>Likely reason</a:t>
             </a:r>
           </a:p>
           <a:p>
@@ -21980,7 +21980,7 @@
                 <a:latin typeface="Arial"/>
                 <a:cs typeface="Arial"/>
               </a:rPr>
-              <a:t>None of the 7 topics asked for these rules.</a:t>
+              <a:t>We asked for changes and checks.</a:t>
             </a:r>
           </a:p>
           <a:p>
@@ -22004,31 +22004,7 @@
                 <a:latin typeface="Arial"/>
                 <a:cs typeface="Arial"/>
               </a:rPr>
-              <a:t>The rules weren’t among the 5 bugs, and handoffs mostly described changes.</a:t>
-            </a:r>
-          </a:p>
-          <a:p>
-            <a:pPr marL="0" indent="0" algn="l">
-              <a:lnSpc>
-                <a:spcPct val="105000"/>
-              </a:lnSpc>
-              <a:spcBef>
-                <a:spcPts val="0"/>
-              </a:spcBef>
-              <a:spcAft>
-                <a:spcPts val="0"/>
-              </a:spcAft>
-              <a:buNone/>
-            </a:pPr>
-            <a:r>
-              <a:rPr lang="en-SG" sz="1300" b="0" i="0" dirty="0">
-                <a:solidFill>
-                  <a:srgbClr val="D6DDE8"/>
-                </a:solidFill>
-                <a:latin typeface="Arial"/>
-                <a:cs typeface="Arial"/>
-              </a:rPr>
-              <a:t>Not the word limit: handoffs over 200 words left them out too.</a:t>
+              <a:t>We didn’t ask for these rules, but the quiz did.</a:t>
             </a:r>
           </a:p>
         </p:txBody>

</xml_diff>